<commit_message>
Presentation: 12-slide cut with camera, pose-model and statistics slides
Main deck is now 12 slides (about 8.5 min by the speaker notes); the rest
moves to backup. New slides: what each camera sees and why the two are
synced (real frames of the demo throw, side/front frame timeline), what
Sports2D sees on the athlete with the joint angles and the calculations
behind them, and the biomechanics statistics (signal vs noise against
ICC from the metric review, within-athlete Spearman links with bootstrap
CIs, the evidence gate). Conclusion now carries the lessons and Q&A.

Summary figures read the committed 92-throw library (exported with git
archive while the working copy is being re-analysed); camera and body
figures read single frames from the stored clips. Nothing is re-analysed.

Co-Authored-By: Claude Opus 5.5 (1M context) <noreply@anthropic.com>
</commit_message>
<xml_diff>
--- a/docs/presentation/Cornhole Biomechanics Lab - Final.pptx
+++ b/docs/presentation/Cornhole Biomechanics Lab - Final.pptx
@@ -9,23 +9,26 @@
   </p:notesMasterIdLst>
   <p:sldIdLst>
     <p:sldId id="256" r:id="rId6"/>
+    <p:sldId id="258" r:id="rId8"/>
+    <p:sldId id="272" r:id="rId23"/>
+    <p:sldId id="273" r:id="rId24"/>
+    <p:sldId id="261" r:id="rId11"/>
+    <p:sldId id="274" r:id="rId25"/>
+    <p:sldId id="264" r:id="rId14"/>
+    <p:sldId id="266" r:id="rId16"/>
+    <p:sldId id="267" r:id="rId17"/>
+    <p:sldId id="275" r:id="rId26"/>
+    <p:sldId id="269" r:id="rId19"/>
+    <p:sldId id="276" r:id="rId27"/>
     <p:sldId id="257" r:id="rId7"/>
-    <p:sldId id="258" r:id="rId8"/>
     <p:sldId id="259" r:id="rId9"/>
     <p:sldId id="260" r:id="rId10"/>
-    <p:sldId id="261" r:id="rId11"/>
+    <p:sldId id="262" r:id="rId12"/>
     <p:sldId id="263" r:id="rId13"/>
-    <p:sldId id="264" r:id="rId14"/>
     <p:sldId id="265" r:id="rId15"/>
-    <p:sldId id="266" r:id="rId16"/>
-    <p:sldId id="267" r:id="rId17"/>
     <p:sldId id="268" r:id="rId18"/>
-    <p:sldId id="272" r:id="rId23"/>
-    <p:sldId id="269" r:id="rId19"/>
     <p:sldId id="270" r:id="rId20"/>
-    <p:sldId id="273" r:id="rId24"/>
     <p:sldId id="271" r:id="rId21"/>
-    <p:sldId id="262" r:id="rId12"/>
   </p:sldIdLst>
   <p:sldSz cy="6858000" cx="12192000"/>
   <p:notesSz cx="6858000" cy="12192000"/>
@@ -2732,7 +2735,7 @@
           <a:lstStyle/>
           <a:p>
             <a:r>
-              <a:t>ELIAM (0:35). Here is the whole data set in one picture. Left: where every bag first touched the board. The hole shots, in blue, landed about 18 inches short and slid in, so the slide is part of a good shot. Top: outcomes per athlete. 18 in the hole, 38 on the board, 36 off. All four release at about 7.5 m/s, yet points per round run from 1.4 to 6.0, so it is consistency, not power, that sets the score. Bottom: for the 44 misses the app could explain above noise, which part it named. The carry is the single biggest part, but the slide along and across the board adds up to 31 against 39 for the flight. So practice time should go to board feel as well as release speed.</a:t>
+              <a:t>EMILY (0:45). Our solution is two phones on tripods and a Mac, no markers and no sensors, and each camera has a job. The side phone sits beside the lane and sees the throw plane: arm swing, trunk lean, wrist speed, and the bag's release speed, angle and height from its arc, then how far short or long it landed and slid. The front phone sits behind the board and sees what the side can't: left and right, trunk side lean, the hand crossing the body, and whether the bag went in the hole. To explain one throw, both must describe the same instant, so we sync them by sound: the athlete claps, every bag thuds, and the app lines up the two soundtracks to plus or minus 17.5 ms. On this throw, side frame 167 is front frame 85. We filmed 4 athletes, 23 takes, 92 throws. Why not alternatives: a mocap lab can't come to practice, wearables see the arm but not the bag, and a sensor in the bag isn't allowed.</a:t>
             </a:r>
           </a:p>
         </p:txBody>
@@ -2802,7 +2805,77 @@
           <a:lstStyle/>
           <a:p>
             <a:r>
-              <a:t>ELIAM (0:25). To sum up. We built a two-phone, sensor-free system that links the body to the release, the landing and the score, and turns each throw into one sentence. We found that speed consistency, not angle or power, drives short and long misses, and that the slide on the board matters almost as much as the flight. What comes next is proving it raises scores, with an alternating-weeks study and a blinded validation check. Measure the throw, explain the miss, coach only what the data supports.</a:t>
+              <a:t>JOHN (0:50). This is what the computer actually sees. Sports2D, an open-source pose model, puts keypoints on the athlete in every frame, from both cameras, with no markers. From those 2D points we compute joint angles with the dot product: here the elbow is at 162 degrees at release, the trunk leans 24 degrees forward, and the arm is 75 degrees from vertical. The front camera at the same instant gives a 9 degree side lean and a 4 degree shoulder tilt. Points are filtered with a 6 Hz zero-phase Butterworth, the biomechanics standard, before any angle or speed, and speeds are central differences normalised by arm length so athletes compare fairly. The bag is pure physics: we fit constant velocity plus gravity to the first 0.12 seconds of flight, giving release speed and angle, and the camera scale is fixed by the board's size and by gravity on the bag's own fall. Every number carries its noise floor, because markerless joint centres are only good to a few centimetres.</a:t>
+            </a:r>
+          </a:p>
+        </p:txBody>
+      </p:sp>
+      <p:sp>
+        <p:nvSpPr>
+          <p:cNvPr id="4" name="Slide Number Placeholder 3"/>
+          <p:cNvSpPr>
+            <a:spLocks noGrp="1"/>
+          </p:cNvSpPr>
+          <p:nvPr>
+            <p:ph type="sldNum" idx="12"/>
+          </p:nvPr>
+        </p:nvSpPr>
+        <p:spPr/>
+      </p:sp>
+    </p:spTree>
+  </p:cSld>
+  <p:clrMapOvr>
+    <a:masterClrMapping/>
+  </p:clrMapOvr>
+</p:notes>
+</file>
+
+<file path=ppt/notesSlides/notesSlide19.xml><?xml version="1.0" encoding="utf-8"?>
+<p:notes xmlns:a="http://schemas.openxmlformats.org/drawingml/2006/main" xmlns:p="http://schemas.openxmlformats.org/presentationml/2006/main" xmlns:r="http://schemas.openxmlformats.org/officeDocument/2006/relationships">
+  <p:cSld>
+    <p:spTree>
+      <p:nvGrpSpPr>
+        <p:cNvPr id="1" name=""/>
+        <p:cNvGrpSpPr/>
+        <p:nvPr/>
+      </p:nvGrpSpPr>
+      <p:grpSpPr>
+        <a:xfrm>
+          <a:off x="0" y="0"/>
+          <a:ext cx="0" cy="0"/>
+          <a:chOff x="0" y="0"/>
+          <a:chExt cx="0" cy="0"/>
+        </a:xfrm>
+      </p:grpSpPr>
+      <p:sp>
+        <p:nvSpPr>
+          <p:cNvPr id="2" name="Slide Image Placeholder 1"/>
+          <p:cNvSpPr>
+            <a:spLocks noGrp="1"/>
+          </p:cNvSpPr>
+          <p:nvPr>
+            <p:ph type="sldImg" idx="3"/>
+          </p:nvPr>
+        </p:nvSpPr>
+        <p:spPr/>
+      </p:sp>
+      <p:sp>
+        <p:nvSpPr>
+          <p:cNvPr id="3" name="Notes Placeholder 2"/>
+          <p:cNvSpPr>
+            <a:spLocks noGrp="1"/>
+          </p:cNvSpPr>
+          <p:nvPr>
+            <p:ph type="body" idx="1"/>
+          </p:nvPr>
+        </p:nvSpPr>
+        <p:spPr/>
+        <p:txBody>
+          <a:bodyPr/>
+          <a:lstStyle/>
+          <a:p>
+            <a:r>
+              <a:t>JOHN (0:50). For a sport scientist the key question is: is a difference real, or noise? Left: every metric, plotted by how much it varies throw to throw compared with its measurement noise, against the ICC, the share of variation that is between athletes. Release speed is the striking one: an ICC near zero and a spread twice its noise, so every athlete wobbles in speed from throw to throw, and that is trainable. Backswing and trunk lean have ICCs of 0.9 and above: they are each athlete's style, stable, so we don't coach them away. Right: within-athlete Spearman correlations with bootstrap intervals. Physics shows up clearly: release angle predicts apex height for all four. But no release value predicts points yet with 20 to 28 throws each, and we report that honestly. That is why advice passes an evidence gate: enough throws, a large Cliff's delta after Bonferroni, bigger than noise, and a bootstrap interval that excludes zero.</a:t>
             </a:r>
           </a:p>
         </p:txBody>
@@ -2985,6 +3058,146 @@
 </p:notes>
 </file>
 
+<file path=ppt/notesSlides/notesSlide20.xml><?xml version="1.0" encoding="utf-8"?>
+<p:notes xmlns:a="http://schemas.openxmlformats.org/drawingml/2006/main" xmlns:p="http://schemas.openxmlformats.org/presentationml/2006/main" xmlns:r="http://schemas.openxmlformats.org/officeDocument/2006/relationships">
+  <p:cSld>
+    <p:spTree>
+      <p:nvGrpSpPr>
+        <p:cNvPr id="1" name=""/>
+        <p:cNvGrpSpPr/>
+        <p:nvPr/>
+      </p:nvGrpSpPr>
+      <p:grpSpPr>
+        <a:xfrm>
+          <a:off x="0" y="0"/>
+          <a:ext cx="0" cy="0"/>
+          <a:chOff x="0" y="0"/>
+          <a:chExt cx="0" cy="0"/>
+        </a:xfrm>
+      </p:grpSpPr>
+      <p:sp>
+        <p:nvSpPr>
+          <p:cNvPr id="2" name="Slide Image Placeholder 1"/>
+          <p:cNvSpPr>
+            <a:spLocks noGrp="1"/>
+          </p:cNvSpPr>
+          <p:nvPr>
+            <p:ph type="sldImg" idx="3"/>
+          </p:nvPr>
+        </p:nvSpPr>
+        <p:spPr/>
+      </p:sp>
+      <p:sp>
+        <p:nvSpPr>
+          <p:cNvPr id="3" name="Notes Placeholder 2"/>
+          <p:cNvSpPr>
+            <a:spLocks noGrp="1"/>
+          </p:cNvSpPr>
+          <p:nvPr>
+            <p:ph type="body" idx="1"/>
+          </p:nvPr>
+        </p:nvSpPr>
+        <p:spPr/>
+        <p:txBody>
+          <a:bodyPr/>
+          <a:lstStyle/>
+          <a:p>
+            <a:r>
+              <a:t>ELIAM (0:35). Here is the whole data set. Left: where every bag first touched the board. The hole shots, in blue, landed about 18 inches short and slid in, so the slide is part of a good shot. Top: 18 in the hole, 38 on the board, 36 off. All four release at about 7.5 m/s, yet points per round run from 1.4 to 6.0: consistency, not power, sets the score. Bottom: for the 44 misses the app could explain above noise, the carry is the single biggest part, but the slide along and across the board adds up to 31 against 39 for the flight. So practice should include board feel, not only the arm.</a:t>
+            </a:r>
+          </a:p>
+        </p:txBody>
+      </p:sp>
+      <p:sp>
+        <p:nvSpPr>
+          <p:cNvPr id="4" name="Slide Number Placeholder 3"/>
+          <p:cNvSpPr>
+            <a:spLocks noGrp="1"/>
+          </p:cNvSpPr>
+          <p:nvPr>
+            <p:ph type="sldNum" idx="12"/>
+          </p:nvPr>
+        </p:nvSpPr>
+        <p:spPr/>
+      </p:sp>
+    </p:spTree>
+  </p:cSld>
+  <p:clrMapOvr>
+    <a:masterClrMapping/>
+  </p:clrMapOvr>
+</p:notes>
+</file>
+
+<file path=ppt/notesSlides/notesSlide21.xml><?xml version="1.0" encoding="utf-8"?>
+<p:notes xmlns:a="http://schemas.openxmlformats.org/drawingml/2006/main" xmlns:p="http://schemas.openxmlformats.org/presentationml/2006/main" xmlns:r="http://schemas.openxmlformats.org/officeDocument/2006/relationships">
+  <p:cSld>
+    <p:spTree>
+      <p:nvGrpSpPr>
+        <p:cNvPr id="1" name=""/>
+        <p:cNvGrpSpPr/>
+        <p:nvPr/>
+      </p:nvGrpSpPr>
+      <p:grpSpPr>
+        <a:xfrm>
+          <a:off x="0" y="0"/>
+          <a:ext cx="0" cy="0"/>
+          <a:chOff x="0" y="0"/>
+          <a:chExt cx="0" cy="0"/>
+        </a:xfrm>
+      </p:grpSpPr>
+      <p:sp>
+        <p:nvSpPr>
+          <p:cNvPr id="2" name="Slide Image Placeholder 1"/>
+          <p:cNvSpPr>
+            <a:spLocks noGrp="1"/>
+          </p:cNvSpPr>
+          <p:nvPr>
+            <p:ph type="sldImg" idx="3"/>
+          </p:nvPr>
+        </p:nvSpPr>
+        <p:spPr/>
+      </p:sp>
+      <p:sp>
+        <p:nvSpPr>
+          <p:cNvPr id="3" name="Notes Placeholder 2"/>
+          <p:cNvSpPr>
+            <a:spLocks noGrp="1"/>
+          </p:cNvSpPr>
+          <p:nvPr>
+            <p:ph type="body" idx="1"/>
+          </p:nvPr>
+        </p:nvSpPr>
+        <p:spPr/>
+        <p:txBody>
+          <a:bodyPr/>
+          <a:lstStyle/>
+          <a:p>
+            <a:r>
+              <a:t>ELIAM (0:30). To sum up: we built a two-phone, sensor-free system that links the body to the release, landing and score. We found speed consistency drives short and long, and the slide matters almost as much as the flight. Next is proving it raises scores. What we learned: the hardest part was a red bag on a red board; the surprise was that everyone throws at the same speed; we'd use a contrasting bag and a 120 fps camera; and what kept us up was giving advice from noise, which is why we built the evidence gate. Measure the throw, explain the miss, coach only what the data supports. Questions? Q&amp;A owners: Emily (sport and coaching), John (metrics and statistics), Berk (app, tracking, sync), Eliam (results and limits).</a:t>
+            </a:r>
+          </a:p>
+        </p:txBody>
+      </p:sp>
+      <p:sp>
+        <p:nvSpPr>
+          <p:cNvPr id="4" name="Slide Number Placeholder 3"/>
+          <p:cNvSpPr>
+            <a:spLocks noGrp="1"/>
+          </p:cNvSpPr>
+          <p:nvPr>
+            <p:ph type="sldNum" idx="12"/>
+          </p:nvPr>
+        </p:nvSpPr>
+        <p:spPr/>
+      </p:sp>
+    </p:spTree>
+  </p:cSld>
+  <p:clrMapOvr>
+    <a:masterClrMapping/>
+  </p:clrMapOvr>
+</p:notes>
+</file>
+
 <file path=ppt/notesSlides/notesSlide3.xml><?xml version="1.0" encoding="utf-8"?>
 <p:notes xmlns:a="http://schemas.openxmlformats.org/drawingml/2006/main" xmlns:r="http://schemas.openxmlformats.org/officeDocument/2006/relationships" xmlns:mc="http://schemas.openxmlformats.org/markup-compatibility/2006" xmlns:mv="urn:schemas-microsoft-com:mac:vml" xmlns:p="http://schemas.openxmlformats.org/presentationml/2006/main" xmlns:c="http://schemas.openxmlformats.org/drawingml/2006/chart" xmlns:dgm="http://schemas.openxmlformats.org/drawingml/2006/diagram" xmlns:o="urn:schemas-microsoft-com:office:office" xmlns:v="urn:schemas-microsoft-com:vml" xmlns:pvml="urn:schemas-microsoft-com:office:powerpoint" xmlns:com="http://schemas.openxmlformats.org/drawingml/2006/compatibility" xmlns:p14="http://schemas.microsoft.com/office/powerpoint/2010/main" xmlns:p15="http://schemas.microsoft.com/office/powerpoint/2012/main" xmlns:ahyp="http://schemas.microsoft.com/office/drawing/2018/hyperlinkcolor" showMasterPhAnim="0" showMasterSp="0">
   <p:cSld>
@@ -4023,7 +4236,7 @@
           <a:lstStyle/>
           <a:p>
             <a:r>
-              <a:t>BERK (0:40). Here's how the app works. The input is one take: a side video and a front video of four throws. The coach drops the folder on the app, and a Python engine runs on the Mac, about two minutes per throw, one at a time. Six steps. One: pair the videos, sync them by sound, which I'll explain next, and find the four throws. Two: track 26 body points with the open-source Sports2D pose model and smooth them with a 6 Hz filter, the standard in biomechanics. Three: find the bag. A gym is full of motion, so we keep only paths that curve down like a real falling bag. That physics check throws out people walking and arms swinging, with no training data needed. Four: turn pixels into metres using the board's known size, checked against gravity: the bag must fall at 9.81 m/s². Five: compute release speed, angle and height from the first 0.12 s of flight, plus where it landed and whether it went in. Six: split each miss into parts and write one sentence, only when the evidence supports it. [Strip below the boxes: this is one real throw, Player 1 Take 6 Throw 1. Sync shifted the front phone 213 ms; the pose model finds the body; 68 bag points follow a drag-free arc; the bag's own fall gives 211 px per metre and 10.0 m/s², close to gravity; release 7.7 m/s at 41°; it landed short and slid in, so the advice is: nothing to change.]</a:t>
+              <a:t>BERK (0:40). This is the app end to end, on one real throw. The coach drops a take folder on the Mac; a Python engine runs about two minutes per throw. One: sync the phones by sound, here a 213 ms shift. Two: Sports2D finds the body on every frame and we smooth it at 6 Hz. Three: find the bag; we keep only a path that falls like a real bag, 68 points here, against the dashed drag-free fit. Four: turn pixels into metres, 211 px per metre, checked by the bag's own fall: 10.0 m/s², close to gravity. Five: release 7.7 m/s at 41 degrees, 0.95 m high; it landed short and slid into the hole. Six: the advice. A made throw gets no corrections: in the hole, nothing to change.</a:t>
             </a:r>
           </a:p>
         </p:txBody>
@@ -6461,7 +6674,7 @@
                 <a:cs typeface="Times New Roman"/>
                 <a:sym typeface="Times New Roman"/>
               </a:rPr>
-              <a:t>PART 3 · TWO-CAMERA SYNCHRONISATION</a:t>
+              <a:t>BACKUP · TWO-CAMERA SYNCHRONISATION</a:t>
             </a:r>
             <a:endParaRPr b="0" i="0" sz="1200" u="none" cap="none" strike="noStrike">
               <a:solidFill>
@@ -8480,7 +8693,7 @@
                 <a:cs typeface="Times New Roman"/>
                 <a:sym typeface="Times New Roman"/>
               </a:rPr>
-              <a:t>Berk Kasimcan · 9 / 17</a:t>
+              <a:t>Berk Kasimcan · backup</a:t>
             </a:r>
             <a:endParaRPr b="0" i="0" sz="1200" u="none" cap="none" strike="noStrike">
               <a:solidFill>
@@ -10183,7 +10396,7 @@
                 <a:cs typeface="Times New Roman"/>
                 <a:sym typeface="Times New Roman"/>
               </a:rPr>
-              <a:t>Berk Kasimcan · 10 / 17</a:t>
+              <a:t>Berk Kasimcan · 8 / 12</a:t>
             </a:r>
             <a:endParaRPr b="0" i="0" sz="1200" u="none" cap="none" strike="noStrike">
               <a:solidFill>
@@ -11917,7 +12130,7 @@
                 <a:cs typeface="Times New Roman"/>
                 <a:sym typeface="Times New Roman"/>
               </a:rPr>
-              <a:t>Berk Kasimcan · 11 / 17</a:t>
+              <a:t>Berk Kasimcan · 9 / 12</a:t>
             </a:r>
             <a:endParaRPr b="0" i="0" sz="1200" u="none" cap="none" strike="noStrike">
               <a:solidFill>
@@ -12015,7 +12228,7 @@
                 <a:cs typeface="Times New Roman"/>
                 <a:sym typeface="Times New Roman"/>
               </a:rPr>
-              <a:t>PART 4 · WHAT OUR DATA REVEALED</a:t>
+              <a:t>BACKUP · WHAT OUR DATA REVEALED</a:t>
             </a:r>
             <a:endParaRPr b="0" i="0" sz="1200" u="none" cap="none" strike="noStrike">
               <a:solidFill>
@@ -13914,7 +14127,7 @@
                 <a:cs typeface="Times New Roman"/>
                 <a:sym typeface="Times New Roman"/>
               </a:rPr>
-              <a:t>Eliam Chang · 12 / 17</a:t>
+              <a:t>Eliam Chang · backup</a:t>
             </a:r>
             <a:endParaRPr b="0" i="0" sz="1200" u="none" cap="none" strike="noStrike">
               <a:solidFill>
@@ -16708,7 +16921,7 @@
                 <a:cs typeface="Times New Roman"/>
                 <a:sym typeface="Times New Roman"/>
               </a:rPr>
-              <a:t>Eliam Chang · 14 / 17</a:t>
+              <a:t>Eliam Chang · 11 / 12</a:t>
             </a:r>
             <a:endParaRPr b="0" i="0" sz="1200" u="none" cap="none" strike="noStrike">
               <a:solidFill>
@@ -16806,7 +17019,7 @@
                 <a:cs typeface="Times New Roman"/>
                 <a:sym typeface="Times New Roman"/>
               </a:rPr>
-              <a:t>PART 4 · THE BENEFIT FOR VANDERBILT ATHLETICS</a:t>
+              <a:t>BACKUP · THE BENEFIT FOR VANDERBILT ATHLETICS</a:t>
             </a:r>
             <a:endParaRPr b="0" i="0" sz="1200" u="none" cap="none" strike="noStrike">
               <a:solidFill>
@@ -19568,7 +19781,7 @@
                 <a:cs typeface="Times New Roman"/>
                 <a:sym typeface="Times New Roman"/>
               </a:rPr>
-              <a:t>Eliam Chang · 15 / 17</a:t>
+              <a:t>Eliam Chang · backup</a:t>
             </a:r>
             <a:endParaRPr b="0" i="0" sz="1200" u="none" cap="none" strike="noStrike">
               <a:solidFill>
@@ -19666,7 +19879,7 @@
                 <a:cs typeface="Times New Roman"/>
                 <a:sym typeface="Times New Roman"/>
               </a:rPr>
-              <a:t>WHAT WE LEARNED</a:t>
+              <a:t>BACKUP · WHAT WE LEARNED</a:t>
             </a:r>
             <a:endParaRPr b="0" i="0" sz="1200" u="none" cap="none" strike="noStrike">
               <a:solidFill>
@@ -20722,7 +20935,7 @@
                 <a:cs typeface="Times New Roman"/>
                 <a:sym typeface="Times New Roman"/>
               </a:rPr>
-              <a:t>Eliam Chang · 17 / 17</a:t>
+              <a:t>Eliam Chang · backup</a:t>
             </a:r>
             <a:endParaRPr b="0" i="0" sz="1200" u="none" cap="none" strike="noStrike">
               <a:solidFill>
@@ -20763,7 +20976,7 @@
       <p:grpSpPr/>
       <p:sp>
         <p:nvSpPr>
-          <p:cNvPr id="363" name="Google Shape;363;p13"/>
+          <p:cNvPr id="100" name="Google Shape;100;p4"/>
           <p:cNvSpPr/>
           <p:nvPr/>
         </p:nvSpPr>
@@ -20813,7 +21026,7 @@
                 <a:cs typeface="Times New Roman"/>
                 <a:sym typeface="Times New Roman"/>
               </a:rPr>
-              <a:t>PART 4 · WHERE THE 92 THROWS WENT</a:t>
+              <a:t>PART 2 · OUR SOLUTION AND WHY</a:t>
             </a:r>
             <a:endParaRPr b="0" i="0" sz="1200" u="none" cap="none" strike="noStrike">
               <a:solidFill>
@@ -20829,7 +21042,7 @@
       </p:sp>
       <p:sp>
         <p:nvSpPr>
-          <p:cNvPr id="364" name="Google Shape;364;p13"/>
+          <p:cNvPr id="101" name="Google Shape;101;p4"/>
           <p:cNvSpPr txBox="1"/>
           <p:nvPr>
             <p:ph type="title"/>
@@ -20881,7 +21094,7 @@
                 <a:cs typeface="Times New Roman"/>
                 <a:sym typeface="Times New Roman"/>
               </a:rPr>
-              <a:t>Same release, very different results</a:t>
+              <a:t>Two cameras, two jobs, one timeline</a:t>
             </a:r>
             <a:endParaRPr sz="3000"/>
           </a:p>
@@ -20889,7 +21102,7 @@
       </p:sp>
       <p:sp>
         <p:nvSpPr>
-          <p:cNvPr id="392" name="Google Shape;392;p13"/>
+          <p:cNvPr id="113" name="Google Shape;113;p4"/>
           <p:cNvSpPr/>
           <p:nvPr/>
         </p:nvSpPr>
@@ -20955,14 +21168,14 @@
       </p:sp>
       <p:sp>
         <p:nvSpPr>
-          <p:cNvPr id="393" name="Google Shape;393;p13"/>
+          <p:cNvPr id="114" name="Google Shape;114;p4"/>
           <p:cNvSpPr/>
           <p:nvPr/>
         </p:nvSpPr>
         <p:spPr>
           <a:xfrm>
-            <a:off x="9758878" y="6238280"/>
-            <a:ext cx="1620322" cy="238720"/>
+            <a:off x="9982240" y="6238280"/>
+            <a:ext cx="1396960" cy="238720"/>
           </a:xfrm>
           <a:prstGeom prst="rect">
             <a:avLst/>
@@ -21005,7 +21218,7 @@
                 <a:cs typeface="Times New Roman"/>
                 <a:sym typeface="Times New Roman"/>
               </a:rPr>
-              <a:t>Eliam Chang · 13 / 17</a:t>
+              <a:t>Emily Park · 3 / 12</a:t>
             </a:r>
             <a:endParaRPr b="0" i="0" sz="1200" u="none" cap="none" strike="noStrike">
               <a:solidFill>
@@ -21019,16 +21232,174 @@
           </a:p>
         </p:txBody>
       </p:sp>
-      <p:sp>
-        <p:nvSpPr>
-          <p:cNvPr id="394" name="Rounded Rectangle 393"/>
+      <p:pic>
+        <p:nvPicPr>
+          <p:cNvPr id="115" name="Picture 114" descr="camera_side.png"/>
+          <p:cNvPicPr>
+            <a:picLocks noChangeAspect="1"/>
+          </p:cNvPicPr>
+          <p:nvPr/>
+        </p:nvPicPr>
+        <p:blipFill>
+          <a:blip r:embed="rId2"/>
+          <a:stretch>
+            <a:fillRect/>
+          </a:stretch>
+        </p:blipFill>
+        <p:spPr>
+          <a:xfrm>
+            <a:off x="822960" y="1691640"/>
+            <a:ext cx="7147355" cy="2514600"/>
+          </a:xfrm>
+          <a:prstGeom prst="rect">
+            <a:avLst/>
+          </a:prstGeom>
+        </p:spPr>
+      </p:pic>
+      <p:pic>
+        <p:nvPicPr>
+          <p:cNvPr id="116" name="Picture 115" descr="camera_front.png"/>
+          <p:cNvPicPr>
+            <a:picLocks noChangeAspect="1"/>
+          </p:cNvPicPr>
+          <p:nvPr/>
+        </p:nvPicPr>
+        <p:blipFill>
+          <a:blip r:embed="rId3"/>
+          <a:stretch>
+            <a:fillRect/>
+          </a:stretch>
+        </p:blipFill>
+        <p:spPr>
+          <a:xfrm>
+            <a:off x="8352586" y="1691640"/>
+            <a:ext cx="3022814" cy="2514600"/>
+          </a:xfrm>
+          <a:prstGeom prst="rect">
+            <a:avLst/>
+          </a:prstGeom>
+        </p:spPr>
+      </p:pic>
+      <p:sp>
+        <p:nvSpPr>
+          <p:cNvPr id="117" name="TextBox 116"/>
+          <p:cNvSpPr txBox="1"/>
+          <p:nvPr/>
+        </p:nvSpPr>
+        <p:spPr>
+          <a:xfrm>
+            <a:off x="822960" y="4279392"/>
+            <a:ext cx="7301026" cy="731520"/>
+          </a:xfrm>
+          <a:prstGeom prst="rect">
+            <a:avLst/>
+          </a:prstGeom>
+          <a:noFill/>
+        </p:spPr>
+        <p:txBody>
+          <a:bodyPr wrap="square" lIns="0" rIns="0" tIns="0" bIns="0" anchor="t">
+            <a:spAutoFit/>
+          </a:bodyPr>
+          <a:lstStyle/>
+          <a:p>
+            <a:pPr algn="l">
+              <a:lnSpc>
+                <a:spcPct val="115000"/>
+              </a:lnSpc>
+            </a:pPr>
+            <a:r>
+              <a:rPr sz="1150" b="1" i="0">
+                <a:solidFill>
+                  <a:srgbClr val="2F5D8A"/>
+                </a:solidFill>
+                <a:latin typeface="Times New Roman"/>
+              </a:rPr>
+              <a:t>SIDE PHONE · beside the lane · 1080p, 60 fps</a:t>
+            </a:r>
+          </a:p>
+          <a:p>
+            <a:pPr algn="l">
+              <a:lnSpc>
+                <a:spcPct val="115000"/>
+              </a:lnSpc>
+            </a:pPr>
+            <a:r>
+              <a:rPr sz="1150" b="0" i="0">
+                <a:solidFill>
+                  <a:srgbClr val="57514A"/>
+                </a:solidFill>
+                <a:latin typeface="Times New Roman"/>
+              </a:rPr>
+              <a:t>Sees the throw plane (sagittal): arm swing, trunk lean, wrist speed, release speed, angle and height, the flight arc, short / long and the slide.</a:t>
+            </a:r>
+          </a:p>
+        </p:txBody>
+      </p:sp>
+      <p:sp>
+        <p:nvSpPr>
+          <p:cNvPr id="118" name="TextBox 117"/>
+          <p:cNvSpPr txBox="1"/>
+          <p:nvPr/>
+        </p:nvSpPr>
+        <p:spPr>
+          <a:xfrm>
+            <a:off x="8352586" y="4279392"/>
+            <a:ext cx="3022549" cy="731520"/>
+          </a:xfrm>
+          <a:prstGeom prst="rect">
+            <a:avLst/>
+          </a:prstGeom>
+          <a:noFill/>
+        </p:spPr>
+        <p:txBody>
+          <a:bodyPr wrap="square" lIns="0" rIns="0" tIns="0" bIns="0" anchor="t">
+            <a:spAutoFit/>
+          </a:bodyPr>
+          <a:lstStyle/>
+          <a:p>
+            <a:pPr algn="l">
+              <a:lnSpc>
+                <a:spcPct val="110000"/>
+              </a:lnSpc>
+            </a:pPr>
+            <a:r>
+              <a:rPr sz="1100" b="1" i="0">
+                <a:solidFill>
+                  <a:srgbClr val="8A6A2B"/>
+                </a:solidFill>
+                <a:latin typeface="Times New Roman"/>
+              </a:rPr>
+              <a:t>FRONT PHONE · behind the board · 720p, 30 fps</a:t>
+            </a:r>
+          </a:p>
+          <a:p>
+            <a:pPr algn="l">
+              <a:lnSpc>
+                <a:spcPct val="110000"/>
+              </a:lnSpc>
+            </a:pPr>
+            <a:r>
+              <a:rPr sz="1100" b="0" i="0">
+                <a:solidFill>
+                  <a:srgbClr val="57514A"/>
+                </a:solidFill>
+                <a:latin typeface="Times New Roman"/>
+              </a:rPr>
+              <a:t>Sees across the lane (frontal): side lean, shoulder tilt, hand across the body, left / right, hole / board / off.</a:t>
+            </a:r>
+          </a:p>
+        </p:txBody>
+      </p:sp>
+      <p:sp>
+        <p:nvSpPr>
+          <p:cNvPr id="119" name="Rounded Rectangle 118"/>
           <p:cNvSpPr/>
           <p:nvPr/>
         </p:nvSpPr>
         <p:spPr>
           <a:xfrm>
-            <a:off x="822960" y="1600200"/>
-            <a:ext cx="3017520" cy="4434840"/>
+            <a:off x="822960" y="5120640"/>
+            <a:ext cx="10552176" cy="960120"/>
           </a:xfrm>
           <a:prstGeom prst="roundRect">
             <a:avLst>
@@ -21067,14 +21438,14 @@
       </p:sp>
       <p:sp>
         <p:nvSpPr>
-          <p:cNvPr id="395" name="TextBox 394"/>
+          <p:cNvPr id="120" name="TextBox 119"/>
           <p:cNvSpPr txBox="1"/>
           <p:nvPr/>
         </p:nvSpPr>
         <p:spPr>
           <a:xfrm>
-            <a:off x="1005840" y="1755648"/>
-            <a:ext cx="2697480" cy="237744"/>
+            <a:off x="1005840" y="5193792"/>
+            <a:ext cx="4206240" cy="822960"/>
           </a:xfrm>
           <a:prstGeom prst="rect">
             <a:avLst/>
@@ -21089,48 +21460,18 @@
           <a:p>
             <a:pPr algn="l">
               <a:lnSpc>
-                <a:spcPct val="130000"/>
+                <a:spcPct val="112000"/>
               </a:lnSpc>
             </a:pPr>
             <a:r>
-              <a:rPr sz="1400" b="1" i="0">
-                <a:solidFill>
-                  <a:srgbClr val="1C1A17"/>
-                </a:solidFill>
-                <a:latin typeface="Times New Roman"/>
-              </a:rPr>
-              <a:t>First contact on the board</a:t>
-            </a:r>
-          </a:p>
-        </p:txBody>
-      </p:sp>
-      <p:sp>
-        <p:nvSpPr>
-          <p:cNvPr id="396" name="TextBox 395"/>
-          <p:cNvSpPr txBox="1"/>
-          <p:nvPr/>
-        </p:nvSpPr>
-        <p:spPr>
-          <a:xfrm>
-            <a:off x="1005840" y="2011680"/>
-            <a:ext cx="2697480" cy="365760"/>
-          </a:xfrm>
-          <a:prstGeom prst="rect">
-            <a:avLst/>
-          </a:prstGeom>
-          <a:noFill/>
-        </p:spPr>
-        <p:txBody>
-          <a:bodyPr wrap="square" lIns="0" rIns="0" tIns="0" bIns="0" anchor="t">
-            <a:spAutoFit/>
-          </a:bodyPr>
-          <a:lstStyle/>
-          <a:p>
-            <a:pPr algn="l">
-              <a:lnSpc>
-                <a:spcPct val="130000"/>
-              </a:lnSpc>
-            </a:pPr>
+              <a:rPr sz="1100" b="1" i="0">
+                <a:solidFill>
+                  <a:srgbClr val="A8432A"/>
+                </a:solidFill>
+                <a:latin typeface="Times New Roman"/>
+              </a:rPr>
+              <a:t>WHY WE SYNC </a:t>
+            </a:r>
             <a:r>
               <a:rPr sz="1100" b="0" i="0">
                 <a:solidFill>
@@ -21138,310 +21479,14 @@
                 </a:solidFill>
                 <a:latin typeface="Times New Roman"/>
               </a:rPr>
-              <a:t>Each dot is where a bag first touched (81 located).</a:t>
+              <a:t>Release comes from the side; left / right and the result from the front. To explain one throw both must mean the same instant: the clap and bag thuds line the soundtracks up to ±17.5 ms.</a:t>
             </a:r>
           </a:p>
         </p:txBody>
       </p:sp>
       <p:pic>
         <p:nvPicPr>
-          <p:cNvPr id="397" name="Picture 396" descr="landing_map.png"/>
-          <p:cNvPicPr>
-            <a:picLocks noChangeAspect="1"/>
-          </p:cNvPicPr>
-          <p:nvPr/>
-        </p:nvPicPr>
-        <p:blipFill>
-          <a:blip r:embed="rId2"/>
-          <a:stretch>
-            <a:fillRect/>
-          </a:stretch>
-        </p:blipFill>
-        <p:spPr>
-          <a:xfrm>
-            <a:off x="1097280" y="2395728"/>
-            <a:ext cx="2546646" cy="2834640"/>
-          </a:xfrm>
-          <a:prstGeom prst="rect">
-            <a:avLst/>
-          </a:prstGeom>
-        </p:spPr>
-      </p:pic>
-      <p:sp>
-        <p:nvSpPr>
-          <p:cNvPr id="398" name="TextBox 397"/>
-          <p:cNvSpPr txBox="1"/>
-          <p:nvPr/>
-        </p:nvSpPr>
-        <p:spPr>
-          <a:xfrm>
-            <a:off x="1005840" y="5303520"/>
-            <a:ext cx="2697480" cy="640080"/>
-          </a:xfrm>
-          <a:prstGeom prst="rect">
-            <a:avLst/>
-          </a:prstGeom>
-          <a:noFill/>
-        </p:spPr>
-        <p:txBody>
-          <a:bodyPr wrap="square" lIns="0" rIns="0" tIns="0" bIns="0" anchor="t">
-            <a:spAutoFit/>
-          </a:bodyPr>
-          <a:lstStyle/>
-          <a:p>
-            <a:pPr algn="l">
-              <a:lnSpc>
-                <a:spcPct val="130000"/>
-              </a:lnSpc>
-            </a:pPr>
-            <a:r>
-              <a:rPr sz="1200" b="1" i="0">
-                <a:solidFill>
-                  <a:srgbClr val="2F5D8A"/>
-                </a:solidFill>
-                <a:latin typeface="Times New Roman"/>
-              </a:rPr>
-              <a:t>Hole shots land about 18 in short and slide in.</a:t>
-            </a:r>
-          </a:p>
-        </p:txBody>
-      </p:sp>
-      <p:sp>
-        <p:nvSpPr>
-          <p:cNvPr id="399" name="Rounded Rectangle 398"/>
-          <p:cNvSpPr/>
-          <p:nvPr/>
-        </p:nvSpPr>
-        <p:spPr>
-          <a:xfrm>
-            <a:off x="4023360" y="1600200"/>
-            <a:ext cx="7351775" cy="2148840"/>
-          </a:xfrm>
-          <a:prstGeom prst="roundRect">
-            <a:avLst>
-              <a:gd name="adj" fmla="val 2000"/>
-            </a:avLst>
-          </a:prstGeom>
-          <a:solidFill>
-            <a:srgbClr val="FFFEFB"/>
-          </a:solidFill>
-          <a:ln w="12700">
-            <a:solidFill>
-              <a:srgbClr val="E3DCCF"/>
-            </a:solidFill>
-          </a:ln>
-          <a:effectLst/>
-        </p:spPr>
-        <p:style>
-          <a:lnRef idx="1">
-            <a:schemeClr val="accent1"/>
-          </a:lnRef>
-          <a:fillRef idx="3">
-            <a:schemeClr val="accent1"/>
-          </a:fillRef>
-          <a:effectRef idx="2">
-            <a:schemeClr val="accent1"/>
-          </a:effectRef>
-          <a:fontRef idx="minor">
-            <a:schemeClr val="lt1"/>
-          </a:fontRef>
-        </p:style>
-        <p:txBody>
-          <a:bodyPr rtlCol="0" anchor="ctr"/>
-          <a:lstStyle/>
-          <a:p/>
-        </p:txBody>
-      </p:sp>
-      <p:pic>
-        <p:nvPicPr>
-          <p:cNvPr id="400" name="Picture 399" descr="outcomes_by_athlete.png"/>
-          <p:cNvPicPr>
-            <a:picLocks noChangeAspect="1"/>
-          </p:cNvPicPr>
-          <p:nvPr/>
-        </p:nvPicPr>
-        <p:blipFill>
-          <a:blip r:embed="rId3"/>
-          <a:stretch>
-            <a:fillRect/>
-          </a:stretch>
-        </p:blipFill>
-        <p:spPr>
-          <a:xfrm>
-            <a:off x="4160520" y="1719072"/>
-            <a:ext cx="3920471" cy="1874519"/>
-          </a:xfrm>
-          <a:prstGeom prst="rect">
-            <a:avLst/>
-          </a:prstGeom>
-        </p:spPr>
-      </p:pic>
-      <p:sp>
-        <p:nvSpPr>
-          <p:cNvPr id="401" name="TextBox 400"/>
-          <p:cNvSpPr txBox="1"/>
-          <p:nvPr/>
-        </p:nvSpPr>
-        <p:spPr>
-          <a:xfrm>
-            <a:off x="8458200" y="1755648"/>
-            <a:ext cx="2788920" cy="237744"/>
-          </a:xfrm>
-          <a:prstGeom prst="rect">
-            <a:avLst/>
-          </a:prstGeom>
-          <a:noFill/>
-        </p:spPr>
-        <p:txBody>
-          <a:bodyPr wrap="square" lIns="0" rIns="0" tIns="0" bIns="0" anchor="t">
-            <a:spAutoFit/>
-          </a:bodyPr>
-          <a:lstStyle/>
-          <a:p>
-            <a:pPr algn="l">
-              <a:lnSpc>
-                <a:spcPct val="130000"/>
-              </a:lnSpc>
-            </a:pPr>
-            <a:r>
-              <a:rPr sz="1400" b="1" i="0">
-                <a:solidFill>
-                  <a:srgbClr val="1C1A17"/>
-                </a:solidFill>
-                <a:latin typeface="Times New Roman"/>
-              </a:rPr>
-              <a:t>Outcome per athlete</a:t>
-            </a:r>
-          </a:p>
-        </p:txBody>
-      </p:sp>
-      <p:sp>
-        <p:nvSpPr>
-          <p:cNvPr id="402" name="TextBox 401"/>
-          <p:cNvSpPr txBox="1"/>
-          <p:nvPr/>
-        </p:nvSpPr>
-        <p:spPr>
-          <a:xfrm>
-            <a:off x="8458200" y="2029968"/>
-            <a:ext cx="2788920" cy="1097280"/>
-          </a:xfrm>
-          <a:prstGeom prst="rect">
-            <a:avLst/>
-          </a:prstGeom>
-          <a:noFill/>
-        </p:spPr>
-        <p:txBody>
-          <a:bodyPr wrap="square" lIns="0" rIns="0" tIns="0" bIns="0" anchor="t">
-            <a:spAutoFit/>
-          </a:bodyPr>
-          <a:lstStyle/>
-          <a:p>
-            <a:pPr algn="l">
-              <a:lnSpc>
-                <a:spcPct val="130000"/>
-              </a:lnSpc>
-            </a:pPr>
-            <a:r>
-              <a:rPr sz="1200" b="0" i="0">
-                <a:solidFill>
-                  <a:srgbClr val="57514A"/>
-                </a:solidFill>
-                <a:latin typeface="Times New Roman"/>
-              </a:rPr>
-              <a:t>18 hole · 38 board · 36 off. All four release near 7.5 m/s, yet PPR runs from 1.4 to 6.0.</a:t>
-            </a:r>
-          </a:p>
-        </p:txBody>
-      </p:sp>
-      <p:sp>
-        <p:nvSpPr>
-          <p:cNvPr id="403" name="TextBox 402"/>
-          <p:cNvSpPr txBox="1"/>
-          <p:nvPr/>
-        </p:nvSpPr>
-        <p:spPr>
-          <a:xfrm>
-            <a:off x="8458200" y="3154680"/>
-            <a:ext cx="2788920" cy="457200"/>
-          </a:xfrm>
-          <a:prstGeom prst="rect">
-            <a:avLst/>
-          </a:prstGeom>
-          <a:noFill/>
-        </p:spPr>
-        <p:txBody>
-          <a:bodyPr wrap="square" lIns="0" rIns="0" tIns="0" bIns="0" anchor="t">
-            <a:spAutoFit/>
-          </a:bodyPr>
-          <a:lstStyle/>
-          <a:p>
-            <a:pPr algn="l">
-              <a:lnSpc>
-                <a:spcPct val="130000"/>
-              </a:lnSpc>
-            </a:pPr>
-            <a:r>
-              <a:rPr sz="1200" b="1" i="0">
-                <a:solidFill>
-                  <a:srgbClr val="2F5D8A"/>
-                </a:solidFill>
-                <a:latin typeface="Times New Roman"/>
-              </a:rPr>
-              <a:t>→ Consistency, not power, sets the score.</a:t>
-            </a:r>
-          </a:p>
-        </p:txBody>
-      </p:sp>
-      <p:sp>
-        <p:nvSpPr>
-          <p:cNvPr id="404" name="Rounded Rectangle 403"/>
-          <p:cNvSpPr/>
-          <p:nvPr/>
-        </p:nvSpPr>
-        <p:spPr>
-          <a:xfrm>
-            <a:off x="4023360" y="3886200"/>
-            <a:ext cx="7351775" cy="2148840"/>
-          </a:xfrm>
-          <a:prstGeom prst="roundRect">
-            <a:avLst>
-              <a:gd name="adj" fmla="val 2000"/>
-            </a:avLst>
-          </a:prstGeom>
-          <a:solidFill>
-            <a:srgbClr val="FFFEFB"/>
-          </a:solidFill>
-          <a:ln w="12700">
-            <a:solidFill>
-              <a:srgbClr val="E3DCCF"/>
-            </a:solidFill>
-          </a:ln>
-          <a:effectLst/>
-        </p:spPr>
-        <p:style>
-          <a:lnRef idx="1">
-            <a:schemeClr val="accent1"/>
-          </a:lnRef>
-          <a:fillRef idx="3">
-            <a:schemeClr val="accent1"/>
-          </a:fillRef>
-          <a:effectRef idx="2">
-            <a:schemeClr val="accent1"/>
-          </a:effectRef>
-          <a:fontRef idx="minor">
-            <a:schemeClr val="lt1"/>
-          </a:fontRef>
-        </p:style>
-        <p:txBody>
-          <a:bodyPr rtlCol="0" anchor="ctr"/>
-          <a:lstStyle/>
-          <a:p/>
-        </p:txBody>
-      </p:sp>
-      <p:pic>
-        <p:nvPicPr>
-          <p:cNvPr id="405" name="Picture 404" descr="miss_causes.png"/>
+          <p:cNvPr id="121" name="Picture 120" descr="sync_timeline.png"/>
           <p:cNvPicPr>
             <a:picLocks noChangeAspect="1"/>
           </p:cNvPicPr>
@@ -21455,131 +21500,14 @@
         </p:blipFill>
         <p:spPr>
           <a:xfrm>
-            <a:off x="4160520" y="3995928"/>
-            <a:ext cx="3763244" cy="1920240"/>
+            <a:off x="5818632" y="5148072"/>
+            <a:ext cx="4959096" cy="905256"/>
           </a:xfrm>
           <a:prstGeom prst="rect">
             <a:avLst/>
           </a:prstGeom>
         </p:spPr>
       </p:pic>
-      <p:sp>
-        <p:nvSpPr>
-          <p:cNvPr id="406" name="TextBox 405"/>
-          <p:cNvSpPr txBox="1"/>
-          <p:nvPr/>
-        </p:nvSpPr>
-        <p:spPr>
-          <a:xfrm>
-            <a:off x="8458200" y="4041648"/>
-            <a:ext cx="2788920" cy="237744"/>
-          </a:xfrm>
-          <a:prstGeom prst="rect">
-            <a:avLst/>
-          </a:prstGeom>
-          <a:noFill/>
-        </p:spPr>
-        <p:txBody>
-          <a:bodyPr wrap="square" lIns="0" rIns="0" tIns="0" bIns="0" anchor="t">
-            <a:spAutoFit/>
-          </a:bodyPr>
-          <a:lstStyle/>
-          <a:p>
-            <a:pPr algn="l">
-              <a:lnSpc>
-                <a:spcPct val="130000"/>
-              </a:lnSpc>
-            </a:pPr>
-            <a:r>
-              <a:rPr sz="1400" b="1" i="0">
-                <a:solidFill>
-                  <a:srgbClr val="1C1A17"/>
-                </a:solidFill>
-                <a:latin typeface="Times New Roman"/>
-              </a:rPr>
-              <a:t>What each miss came from</a:t>
-            </a:r>
-          </a:p>
-        </p:txBody>
-      </p:sp>
-      <p:sp>
-        <p:nvSpPr>
-          <p:cNvPr id="407" name="TextBox 406"/>
-          <p:cNvSpPr txBox="1"/>
-          <p:nvPr/>
-        </p:nvSpPr>
-        <p:spPr>
-          <a:xfrm>
-            <a:off x="8458200" y="4315968"/>
-            <a:ext cx="2788920" cy="1097280"/>
-          </a:xfrm>
-          <a:prstGeom prst="rect">
-            <a:avLst/>
-          </a:prstGeom>
-          <a:noFill/>
-        </p:spPr>
-        <p:txBody>
-          <a:bodyPr wrap="square" lIns="0" rIns="0" tIns="0" bIns="0" anchor="t">
-            <a:spAutoFit/>
-          </a:bodyPr>
-          <a:lstStyle/>
-          <a:p>
-            <a:pPr algn="l">
-              <a:lnSpc>
-                <a:spcPct val="130000"/>
-              </a:lnSpc>
-            </a:pPr>
-            <a:r>
-              <a:rPr sz="1200" b="0" i="0">
-                <a:solidFill>
-                  <a:srgbClr val="57514A"/>
-                </a:solidFill>
-                <a:latin typeface="Times New Roman"/>
-              </a:rPr>
-              <a:t>Parts the app named above noise in 44 misses. The flight (39) and the slide on the board (31) are close.</a:t>
-            </a:r>
-          </a:p>
-        </p:txBody>
-      </p:sp>
-      <p:sp>
-        <p:nvSpPr>
-          <p:cNvPr id="408" name="TextBox 407"/>
-          <p:cNvSpPr txBox="1"/>
-          <p:nvPr/>
-        </p:nvSpPr>
-        <p:spPr>
-          <a:xfrm>
-            <a:off x="8458200" y="5440680"/>
-            <a:ext cx="2788920" cy="457200"/>
-          </a:xfrm>
-          <a:prstGeom prst="rect">
-            <a:avLst/>
-          </a:prstGeom>
-          <a:noFill/>
-        </p:spPr>
-        <p:txBody>
-          <a:bodyPr wrap="square" lIns="0" rIns="0" tIns="0" bIns="0" anchor="t">
-            <a:spAutoFit/>
-          </a:bodyPr>
-          <a:lstStyle/>
-          <a:p>
-            <a:pPr algn="l">
-              <a:lnSpc>
-                <a:spcPct val="130000"/>
-              </a:lnSpc>
-            </a:pPr>
-            <a:r>
-              <a:rPr sz="1200" b="1" i="0">
-                <a:solidFill>
-                  <a:srgbClr val="A8432A"/>
-                </a:solidFill>
-                <a:latin typeface="Times New Roman"/>
-              </a:rPr>
-              <a:t>→ Train board feel, not only the arm.</a:t>
-            </a:r>
-          </a:p>
-        </p:txBody>
-      </p:sp>
     </p:spTree>
   </p:cSld>
   <p:clrMapOvr>
@@ -21607,7 +21535,7 @@
       <p:grpSpPr/>
       <p:sp>
         <p:nvSpPr>
-          <p:cNvPr id="426" name="Google Shape;426;p15"/>
+          <p:cNvPr id="120" name="Google Shape;120;p5"/>
           <p:cNvSpPr/>
           <p:nvPr/>
         </p:nvSpPr>
@@ -21657,7 +21585,7 @@
                 <a:cs typeface="Times New Roman"/>
                 <a:sym typeface="Times New Roman"/>
               </a:rPr>
-              <a:t>CONCLUSION</a:t>
+              <a:t>PART 2 · WHAT WE MEASURE ON THE ATHLETE</a:t>
             </a:r>
             <a:endParaRPr b="0" i="0" sz="1200" u="none" cap="none" strike="noStrike">
               <a:solidFill>
@@ -21673,7 +21601,7 @@
       </p:sp>
       <p:sp>
         <p:nvSpPr>
-          <p:cNvPr id="427" name="Google Shape;427;p15"/>
+          <p:cNvPr id="121" name="Google Shape;121;p5"/>
           <p:cNvSpPr txBox="1"/>
           <p:nvPr>
             <p:ph type="title"/>
@@ -21725,7 +21653,7 @@
                 <a:cs typeface="Times New Roman"/>
                 <a:sym typeface="Times New Roman"/>
               </a:rPr>
-              <a:t>What we built, what we found, what comes next</a:t>
+              <a:t>What the pose model sees, and what we calculate</a:t>
             </a:r>
             <a:endParaRPr sz="3000"/>
           </a:p>
@@ -21733,7 +21661,7 @@
       </p:sp>
       <p:sp>
         <p:nvSpPr>
-          <p:cNvPr id="454" name="Google Shape;454;p15"/>
+          <p:cNvPr id="152" name="Google Shape;152;p5"/>
           <p:cNvSpPr/>
           <p:nvPr/>
         </p:nvSpPr>
@@ -21799,14 +21727,14 @@
       </p:sp>
       <p:sp>
         <p:nvSpPr>
-          <p:cNvPr id="455" name="Google Shape;455;p15"/>
+          <p:cNvPr id="153" name="Google Shape;153;p5"/>
           <p:cNvSpPr/>
           <p:nvPr/>
         </p:nvSpPr>
         <p:spPr>
           <a:xfrm>
-            <a:off x="9758878" y="6238280"/>
-            <a:ext cx="1620322" cy="238720"/>
+            <a:off x="9901396" y="6238280"/>
+            <a:ext cx="1477804" cy="238720"/>
           </a:xfrm>
           <a:prstGeom prst="rect">
             <a:avLst/>
@@ -21849,7 +21777,7 @@
                 <a:cs typeface="Times New Roman"/>
                 <a:sym typeface="Times New Roman"/>
               </a:rPr>
-              <a:t>Eliam Chang · 16 / 17</a:t>
+              <a:t>John Wilson · 4 / 12</a:t>
             </a:r>
             <a:endParaRPr b="0" i="0" sz="1200" u="none" cap="none" strike="noStrike">
               <a:solidFill>
@@ -21863,16 +21791,166 @@
           </a:p>
         </p:txBody>
       </p:sp>
-      <p:sp>
-        <p:nvSpPr>
-          <p:cNvPr id="456" name="Rounded Rectangle 455"/>
+      <p:pic>
+        <p:nvPicPr>
+          <p:cNvPr id="154" name="Picture 153" descr="body_side.png"/>
+          <p:cNvPicPr>
+            <a:picLocks noChangeAspect="1"/>
+          </p:cNvPicPr>
+          <p:nvPr/>
+        </p:nvPicPr>
+        <p:blipFill>
+          <a:blip r:embed="rId2"/>
+          <a:stretch>
+            <a:fillRect/>
+          </a:stretch>
+        </p:blipFill>
+        <p:spPr>
+          <a:xfrm>
+            <a:off x="822960" y="1691640"/>
+            <a:ext cx="3520440" cy="3520440"/>
+          </a:xfrm>
+          <a:prstGeom prst="rect">
+            <a:avLst/>
+          </a:prstGeom>
+        </p:spPr>
+      </p:pic>
+      <p:pic>
+        <p:nvPicPr>
+          <p:cNvPr id="155" name="Picture 154" descr="body_front.png"/>
+          <p:cNvPicPr>
+            <a:picLocks noChangeAspect="1"/>
+          </p:cNvPicPr>
+          <p:nvPr/>
+        </p:nvPicPr>
+        <p:blipFill>
+          <a:blip r:embed="rId3"/>
+          <a:stretch>
+            <a:fillRect/>
+          </a:stretch>
+        </p:blipFill>
+        <p:spPr>
+          <a:xfrm>
+            <a:off x="4507992" y="1691640"/>
+            <a:ext cx="2399887" cy="3520440"/>
+          </a:xfrm>
+          <a:prstGeom prst="rect">
+            <a:avLst/>
+          </a:prstGeom>
+        </p:spPr>
+      </p:pic>
+      <p:pic>
+        <p:nvPicPr>
+          <p:cNvPr id="156" name="Picture 155" descr="equations.png"/>
+          <p:cNvPicPr>
+            <a:picLocks noChangeAspect="1"/>
+          </p:cNvPicPr>
+          <p:nvPr/>
+        </p:nvPicPr>
+        <p:blipFill>
+          <a:blip r:embed="rId4"/>
+          <a:stretch>
+            <a:fillRect/>
+          </a:stretch>
+        </p:blipFill>
+        <p:spPr>
+          <a:xfrm>
+            <a:off x="7137532" y="1691640"/>
+            <a:ext cx="4237603" cy="2989090"/>
+          </a:xfrm>
+          <a:prstGeom prst="rect">
+            <a:avLst/>
+          </a:prstGeom>
+        </p:spPr>
+      </p:pic>
+      <p:sp>
+        <p:nvSpPr>
+          <p:cNvPr id="157" name="TextBox 156"/>
+          <p:cNvSpPr txBox="1"/>
+          <p:nvPr/>
+        </p:nvSpPr>
+        <p:spPr>
+          <a:xfrm>
+            <a:off x="822960" y="5266944"/>
+            <a:ext cx="3520440" cy="228600"/>
+          </a:xfrm>
+          <a:prstGeom prst="rect">
+            <a:avLst/>
+          </a:prstGeom>
+          <a:noFill/>
+        </p:spPr>
+        <p:txBody>
+          <a:bodyPr wrap="square" lIns="0" rIns="0" tIns="0" bIns="0" anchor="t">
+            <a:spAutoFit/>
+          </a:bodyPr>
+          <a:lstStyle/>
+          <a:p>
+            <a:pPr algn="l">
+              <a:lnSpc>
+                <a:spcPct val="130000"/>
+              </a:lnSpc>
+            </a:pPr>
+            <a:r>
+              <a:rPr sz="1100" b="1" i="0">
+                <a:solidFill>
+                  <a:srgbClr val="2F5D8A"/>
+                </a:solidFill>
+                <a:latin typeface="Times New Roman"/>
+              </a:rPr>
+              <a:t>SIDE · Sports2D keypoints at release</a:t>
+            </a:r>
+          </a:p>
+        </p:txBody>
+      </p:sp>
+      <p:sp>
+        <p:nvSpPr>
+          <p:cNvPr id="158" name="TextBox 157"/>
+          <p:cNvSpPr txBox="1"/>
+          <p:nvPr/>
+        </p:nvSpPr>
+        <p:spPr>
+          <a:xfrm>
+            <a:off x="4507992" y="5266944"/>
+            <a:ext cx="2583820" cy="228600"/>
+          </a:xfrm>
+          <a:prstGeom prst="rect">
+            <a:avLst/>
+          </a:prstGeom>
+          <a:noFill/>
+        </p:spPr>
+        <p:txBody>
+          <a:bodyPr wrap="square" lIns="0" rIns="0" tIns="0" bIns="0" anchor="t">
+            <a:spAutoFit/>
+          </a:bodyPr>
+          <a:lstStyle/>
+          <a:p>
+            <a:pPr algn="l">
+              <a:lnSpc>
+                <a:spcPct val="130000"/>
+              </a:lnSpc>
+            </a:pPr>
+            <a:r>
+              <a:rPr sz="1100" b="1" i="0">
+                <a:solidFill>
+                  <a:srgbClr val="8A6A2B"/>
+                </a:solidFill>
+                <a:latin typeface="Times New Roman"/>
+              </a:rPr>
+              <a:t>FRONT · same instant</a:t>
+            </a:r>
+          </a:p>
+        </p:txBody>
+      </p:sp>
+      <p:sp>
+        <p:nvSpPr>
+          <p:cNvPr id="159" name="Rounded Rectangle 158"/>
           <p:cNvSpPr/>
           <p:nvPr/>
         </p:nvSpPr>
         <p:spPr>
           <a:xfrm>
-            <a:off x="822960" y="1691640"/>
-            <a:ext cx="3383280" cy="2971800"/>
+            <a:off x="822960" y="5532120"/>
+            <a:ext cx="10552176" cy="548640"/>
           </a:xfrm>
           <a:prstGeom prst="roundRect">
             <a:avLst>
@@ -21880,12 +21958,10 @@
             </a:avLst>
           </a:prstGeom>
           <a:solidFill>
-            <a:srgbClr val="FFFEFB"/>
+            <a:srgbClr val="1C1A17"/>
           </a:solidFill>
-          <a:ln w="12700">
-            <a:solidFill>
-              <a:srgbClr val="E3DCCF"/>
-            </a:solidFill>
+          <a:ln>
+            <a:noFill/>
           </a:ln>
           <a:effectLst/>
         </p:spPr>
@@ -21911,14 +21987,14 @@
       </p:sp>
       <p:sp>
         <p:nvSpPr>
-          <p:cNvPr id="457" name="TextBox 456"/>
+          <p:cNvPr id="160" name="TextBox 159"/>
           <p:cNvSpPr txBox="1"/>
           <p:nvPr/>
         </p:nvSpPr>
         <p:spPr>
           <a:xfrm>
-            <a:off x="1024128" y="1874519"/>
-            <a:ext cx="3017520" cy="237744"/>
+            <a:off x="1005840" y="5532120"/>
+            <a:ext cx="10241280" cy="548640"/>
           </a:xfrm>
           <a:prstGeom prst="rect">
             <a:avLst/>
@@ -21926,155 +22002,330 @@
           <a:noFill/>
         </p:spPr>
         <p:txBody>
-          <a:bodyPr wrap="square" lIns="0" rIns="0" tIns="0" bIns="0" anchor="t">
+          <a:bodyPr wrap="square" lIns="0" rIns="0" tIns="0" bIns="0" anchor="ctr">
             <a:spAutoFit/>
           </a:bodyPr>
           <a:lstStyle/>
           <a:p>
             <a:pPr algn="l">
               <a:lnSpc>
-                <a:spcPct val="130000"/>
+                <a:spcPct val="115000"/>
               </a:lnSpc>
             </a:pPr>
             <a:r>
-              <a:rPr sz="1200" b="1" i="0">
-                <a:solidFill>
-                  <a:srgbClr val="2F5D8A"/>
-                </a:solidFill>
-                <a:latin typeface="Times New Roman"/>
-              </a:rPr>
-              <a:t>WE BUILT</a:t>
-            </a:r>
-          </a:p>
-        </p:txBody>
-      </p:sp>
-      <p:sp>
-        <p:nvSpPr>
-          <p:cNvPr id="458" name="TextBox 457"/>
+              <a:rPr sz="1150" b="1" i="0">
+                <a:solidFill>
+                  <a:srgbClr val="C9A45C"/>
+                </a:solidFill>
+                <a:latin typeface="Times New Roman"/>
+              </a:rPr>
+              <a:t>Every number carries its noise. </a:t>
+            </a:r>
+            <a:r>
+              <a:rPr sz="1150" b="0" i="0">
+                <a:solidFill>
+                  <a:srgbClr val="FFFFFF"/>
+                </a:solidFill>
+                <a:latin typeface="Times New Roman"/>
+              </a:rPr>
+              <a:t>Markerless joint centres are good to about 16–48 mm (Needham et al., 2021), so each metric has a noise floor, a status and a grade, and a change smaller than its noise is never coached.</a:t>
+            </a:r>
+          </a:p>
+        </p:txBody>
+      </p:sp>
+    </p:spTree>
+  </p:cSld>
+  <p:clrMapOvr>
+    <a:masterClrMapping/>
+  </p:clrMapOvr>
+</p:sld>
+</file>
+
+<file path=ppt/slides/slide19.xml><?xml version="1.0" encoding="utf-8"?>
+<p:sld xmlns:a="http://schemas.openxmlformats.org/drawingml/2006/main" xmlns:p="http://schemas.openxmlformats.org/presentationml/2006/main" xmlns:r="http://schemas.openxmlformats.org/officeDocument/2006/relationships">
+  <p:cSld>
+    <p:bg>
+      <p:bgPr>
+        <a:solidFill>
+          <a:srgbClr val="FAF8F3"/>
+        </a:solidFill>
+      </p:bgPr>
+    </p:bg>
+    <p:spTree>
+      <p:nvGrpSpPr>
+        <p:cNvPr id="1" name=""/>
+        <p:cNvGrpSpPr/>
+        <p:nvPr/>
+      </p:nvGrpSpPr>
+      <p:grpSpPr/>
+      <p:sp>
+        <p:nvSpPr>
+          <p:cNvPr id="187" name="Google Shape;187;p7"/>
+          <p:cNvSpPr/>
+          <p:nvPr/>
+        </p:nvSpPr>
+        <p:spPr>
+          <a:xfrm>
+            <a:off x="812800" y="812800"/>
+            <a:ext cx="10883392" cy="238720"/>
+          </a:xfrm>
+          <a:prstGeom prst="rect">
+            <a:avLst/>
+          </a:prstGeom>
+          <a:noFill/>
+          <a:ln>
+            <a:noFill/>
+          </a:ln>
+        </p:spPr>
+        <p:txBody>
+          <a:bodyPr anchorCtr="0" anchor="t" bIns="0" lIns="0" spcFirstLastPara="1" rIns="0" wrap="square" tIns="0">
+            <a:normAutofit/>
+          </a:bodyPr>
+          <a:lstStyle/>
+          <a:p>
+            <a:pPr indent="0" lvl="0" marL="0" marR="0" rtl="0" algn="l">
+              <a:lnSpc>
+                <a:spcPct val="140000"/>
+              </a:lnSpc>
+              <a:spcBef>
+                <a:spcPts val="0"/>
+              </a:spcBef>
+              <a:spcAft>
+                <a:spcPts val="0"/>
+              </a:spcAft>
+              <a:buClr>
+                <a:srgbClr val="8A6A2B"/>
+              </a:buClr>
+              <a:buSzPts val="1200"/>
+              <a:buFont typeface="Times New Roman"/>
+              <a:buNone/>
+            </a:pPr>
+            <a:r>
+              <a:rPr b="1" i="0" lang="en-US" spc="100" sz="1200" u="none" cap="none" strike="noStrike">
+                <a:solidFill>
+                  <a:srgbClr val="8A6A2B"/>
+                </a:solidFill>
+                <a:latin typeface="Times New Roman"/>
+                <a:ea typeface="Times New Roman"/>
+                <a:cs typeface="Times New Roman"/>
+                <a:sym typeface="Times New Roman"/>
+              </a:rPr>
+              <a:t>PART 2 · BIOMECHANICS STATISTICS</a:t>
+            </a:r>
+            <a:endParaRPr b="0" i="0" sz="1200" u="none" cap="none" strike="noStrike">
+              <a:solidFill>
+                <a:schemeClr val="dk1"/>
+              </a:solidFill>
+              <a:latin typeface="Times New Roman"/>
+              <a:ea typeface="Times New Roman"/>
+              <a:cs typeface="Times New Roman"/>
+              <a:sym typeface="Times New Roman"/>
+            </a:endParaRPr>
+          </a:p>
+        </p:txBody>
+      </p:sp>
+      <p:sp>
+        <p:nvSpPr>
+          <p:cNvPr id="188" name="Google Shape;188;p7"/>
           <p:cNvSpPr txBox="1"/>
-          <p:nvPr/>
-        </p:nvSpPr>
-        <p:spPr>
-          <a:xfrm>
-            <a:off x="1024128" y="2148840"/>
-            <a:ext cx="3017520" cy="640080"/>
+          <p:nvPr>
+            <p:ph type="title"/>
+          </p:nvPr>
+        </p:nvSpPr>
+        <p:spPr>
+          <a:xfrm>
+            <a:off x="812800" y="1102320"/>
+            <a:ext cx="10883392" cy="444500"/>
           </a:xfrm>
           <a:prstGeom prst="rect">
             <a:avLst/>
           </a:prstGeom>
           <a:noFill/>
-        </p:spPr>
-        <p:txBody>
-          <a:bodyPr wrap="square" lIns="0" rIns="0" tIns="0" bIns="0" anchor="t">
-            <a:spAutoFit/>
-          </a:bodyPr>
-          <a:lstStyle/>
-          <a:p>
-            <a:pPr algn="l">
+          <a:ln>
+            <a:noFill/>
+          </a:ln>
+        </p:spPr>
+        <p:txBody>
+          <a:bodyPr anchorCtr="0" anchor="t" bIns="0" lIns="0" spcFirstLastPara="1" rIns="0" wrap="square" tIns="0">
+            <a:normAutofit/>
+          </a:bodyPr>
+          <a:lstStyle/>
+          <a:p>
+            <a:pPr indent="0" lvl="0" marL="0" rtl="0" algn="l">
               <a:lnSpc>
-                <a:spcPct val="100000"/>
+                <a:spcPct val="110000"/>
               </a:lnSpc>
-            </a:pPr>
-            <a:r>
-              <a:rPr sz="3600" b="1" i="0">
-                <a:solidFill>
-                  <a:srgbClr val="2F5D8A"/>
-                </a:solidFill>
-                <a:latin typeface="Times New Roman"/>
-              </a:rPr>
-              <a:t>2 phones</a:t>
-            </a:r>
-          </a:p>
-        </p:txBody>
-      </p:sp>
-      <p:sp>
-        <p:nvSpPr>
-          <p:cNvPr id="459" name="TextBox 458"/>
-          <p:cNvSpPr txBox="1"/>
-          <p:nvPr/>
-        </p:nvSpPr>
-        <p:spPr>
-          <a:xfrm>
-            <a:off x="1024128" y="2816352"/>
-            <a:ext cx="3017520" cy="274320"/>
+              <a:spcBef>
+                <a:spcPts val="0"/>
+              </a:spcBef>
+              <a:spcAft>
+                <a:spcPts val="0"/>
+              </a:spcAft>
+              <a:buClr>
+                <a:srgbClr val="1C1A17"/>
+              </a:buClr>
+              <a:buSzPts val="3000"/>
+              <a:buFont typeface="Times New Roman"/>
+              <a:buNone/>
+            </a:pPr>
+            <a:r>
+              <a:rPr b="1" i="0" lang="en-US" sz="3000">
+                <a:solidFill>
+                  <a:srgbClr val="1C1A17"/>
+                </a:solidFill>
+                <a:latin typeface="Times New Roman"/>
+                <a:ea typeface="Times New Roman"/>
+                <a:cs typeface="Times New Roman"/>
+                <a:sym typeface="Times New Roman"/>
+              </a:rPr>
+              <a:t>Signal or noise? The statistics behind every cue</a:t>
+            </a:r>
+            <a:endParaRPr sz="3000"/>
+          </a:p>
+        </p:txBody>
+      </p:sp>
+      <p:sp>
+        <p:nvSpPr>
+          <p:cNvPr id="196" name="Google Shape;196;p7"/>
+          <p:cNvSpPr/>
+          <p:nvPr/>
+        </p:nvSpPr>
+        <p:spPr>
+          <a:xfrm>
+            <a:off x="812800" y="6238280"/>
+            <a:ext cx="2092404" cy="238720"/>
           </a:xfrm>
           <a:prstGeom prst="rect">
             <a:avLst/>
           </a:prstGeom>
           <a:noFill/>
-        </p:spPr>
-        <p:txBody>
-          <a:bodyPr wrap="square" lIns="0" rIns="0" tIns="0" bIns="0" anchor="t">
-            <a:spAutoFit/>
-          </a:bodyPr>
-          <a:lstStyle/>
-          <a:p>
-            <a:pPr algn="l">
+          <a:ln>
+            <a:noFill/>
+          </a:ln>
+        </p:spPr>
+        <p:txBody>
+          <a:bodyPr anchorCtr="0" anchor="t" bIns="0" lIns="0" spcFirstLastPara="1" rIns="0" wrap="square" tIns="0">
+            <a:normAutofit/>
+          </a:bodyPr>
+          <a:lstStyle/>
+          <a:p>
+            <a:pPr indent="0" lvl="0" marL="0" marR="0" rtl="0" algn="l">
               <a:lnSpc>
-                <a:spcPct val="130000"/>
+                <a:spcPct val="140000"/>
               </a:lnSpc>
-            </a:pPr>
-            <a:r>
-              <a:rPr sz="1200" b="0" i="1">
-                <a:solidFill>
-                  <a:srgbClr val="1C1A17"/>
-                </a:solidFill>
-                <a:latin typeface="Times New Roman"/>
-              </a:rPr>
-              <a:t>and a Mac, no sensors</a:t>
-            </a:r>
-          </a:p>
-        </p:txBody>
-      </p:sp>
-      <p:sp>
-        <p:nvSpPr>
-          <p:cNvPr id="460" name="TextBox 459"/>
-          <p:cNvSpPr txBox="1"/>
-          <p:nvPr/>
-        </p:nvSpPr>
-        <p:spPr>
-          <a:xfrm>
-            <a:off x="1024128" y="3246120"/>
-            <a:ext cx="3017520" cy="1463040"/>
+              <a:spcBef>
+                <a:spcPts val="0"/>
+              </a:spcBef>
+              <a:spcAft>
+                <a:spcPts val="0"/>
+              </a:spcAft>
+              <a:buClr>
+                <a:srgbClr val="6E665C"/>
+              </a:buClr>
+              <a:buSzPts val="1200"/>
+              <a:buFont typeface="Times New Roman"/>
+              <a:buNone/>
+            </a:pPr>
+            <a:r>
+              <a:rPr b="0" i="0" lang="en-US" sz="1200" u="none" cap="none" strike="noStrike">
+                <a:solidFill>
+                  <a:srgbClr val="6E665C"/>
+                </a:solidFill>
+                <a:latin typeface="Times New Roman"/>
+                <a:ea typeface="Times New Roman"/>
+                <a:cs typeface="Times New Roman"/>
+                <a:sym typeface="Times New Roman"/>
+              </a:rPr>
+              <a:t>Cornhole Biomechanics Lab</a:t>
+            </a:r>
+            <a:endParaRPr b="0" i="0" sz="1200" u="none" cap="none" strike="noStrike">
+              <a:solidFill>
+                <a:schemeClr val="dk1"/>
+              </a:solidFill>
+              <a:latin typeface="Times New Roman"/>
+              <a:ea typeface="Times New Roman"/>
+              <a:cs typeface="Times New Roman"/>
+              <a:sym typeface="Times New Roman"/>
+            </a:endParaRPr>
+          </a:p>
+        </p:txBody>
+      </p:sp>
+      <p:sp>
+        <p:nvSpPr>
+          <p:cNvPr id="197" name="Google Shape;197;p7"/>
+          <p:cNvSpPr/>
+          <p:nvPr/>
+        </p:nvSpPr>
+        <p:spPr>
+          <a:xfrm>
+            <a:off x="9901396" y="6238280"/>
+            <a:ext cx="1477804" cy="238720"/>
           </a:xfrm>
           <a:prstGeom prst="rect">
             <a:avLst/>
           </a:prstGeom>
           <a:noFill/>
-        </p:spPr>
-        <p:txBody>
-          <a:bodyPr wrap="square" lIns="0" rIns="0" tIns="0" bIns="0" anchor="t">
-            <a:spAutoFit/>
-          </a:bodyPr>
-          <a:lstStyle/>
-          <a:p>
-            <a:pPr algn="l">
+          <a:ln>
+            <a:noFill/>
+          </a:ln>
+        </p:spPr>
+        <p:txBody>
+          <a:bodyPr anchorCtr="0" anchor="t" bIns="0" lIns="0" spcFirstLastPara="1" rIns="0" wrap="square" tIns="0">
+            <a:normAutofit/>
+          </a:bodyPr>
+          <a:lstStyle/>
+          <a:p>
+            <a:pPr indent="0" lvl="0" marL="0" marR="0" rtl="0" algn="r">
               <a:lnSpc>
-                <a:spcPct val="130000"/>
+                <a:spcPct val="140000"/>
               </a:lnSpc>
-            </a:pPr>
-            <a:r>
-              <a:rPr sz="1200" b="0" i="0">
-                <a:solidFill>
-                  <a:srgbClr val="57514A"/>
-                </a:solidFill>
-                <a:latin typeface="Times New Roman"/>
-              </a:rPr>
-              <a:t>A system that links the body to the release, the landing and the score, synced by sound and checked against gravity, then gives one sentence per throw.</a:t>
-            </a:r>
-          </a:p>
-        </p:txBody>
-      </p:sp>
-      <p:sp>
-        <p:nvSpPr>
-          <p:cNvPr id="461" name="Rounded Rectangle 460"/>
+              <a:spcBef>
+                <a:spcPts val="0"/>
+              </a:spcBef>
+              <a:spcAft>
+                <a:spcPts val="0"/>
+              </a:spcAft>
+              <a:buClr>
+                <a:srgbClr val="6E665C"/>
+              </a:buClr>
+              <a:buSzPts val="1200"/>
+              <a:buFont typeface="Times New Roman"/>
+              <a:buNone/>
+            </a:pPr>
+            <a:r>
+              <a:rPr b="0" i="0" lang="en-US" sz="1200" u="none" cap="none" strike="noStrike">
+                <a:solidFill>
+                  <a:srgbClr val="6E665C"/>
+                </a:solidFill>
+                <a:latin typeface="Times New Roman"/>
+                <a:ea typeface="Times New Roman"/>
+                <a:cs typeface="Times New Roman"/>
+                <a:sym typeface="Times New Roman"/>
+              </a:rPr>
+              <a:t>John Wilson · 6 / 12</a:t>
+            </a:r>
+            <a:endParaRPr b="0" i="0" sz="1200" u="none" cap="none" strike="noStrike">
+              <a:solidFill>
+                <a:schemeClr val="dk1"/>
+              </a:solidFill>
+              <a:latin typeface="Times New Roman"/>
+              <a:ea typeface="Times New Roman"/>
+              <a:cs typeface="Times New Roman"/>
+              <a:sym typeface="Times New Roman"/>
+            </a:endParaRPr>
+          </a:p>
+        </p:txBody>
+      </p:sp>
+      <p:sp>
+        <p:nvSpPr>
+          <p:cNvPr id="198" name="Rounded Rectangle 197"/>
           <p:cNvSpPr/>
           <p:nvPr/>
         </p:nvSpPr>
         <p:spPr>
           <a:xfrm>
-            <a:off x="4407408" y="1691640"/>
-            <a:ext cx="3383280" cy="2971800"/>
+            <a:off x="822960" y="1691640"/>
+            <a:ext cx="5166360" cy="3749039"/>
           </a:xfrm>
           <a:prstGeom prst="roundRect">
             <a:avLst>
@@ -22113,14 +22364,14 @@
       </p:sp>
       <p:sp>
         <p:nvSpPr>
-          <p:cNvPr id="462" name="TextBox 461"/>
+          <p:cNvPr id="199" name="TextBox 198"/>
           <p:cNvSpPr txBox="1"/>
           <p:nvPr/>
         </p:nvSpPr>
         <p:spPr>
           <a:xfrm>
-            <a:off x="4608576" y="1874519"/>
-            <a:ext cx="3017520" cy="237744"/>
+            <a:off x="1005840" y="1801368"/>
+            <a:ext cx="4800600" cy="237744"/>
           </a:xfrm>
           <a:prstGeom prst="rect">
             <a:avLst/>
@@ -22139,27 +22390,51 @@
               </a:lnSpc>
             </a:pPr>
             <a:r>
-              <a:rPr sz="1200" b="1" i="0">
-                <a:solidFill>
-                  <a:srgbClr val="8A6A2B"/>
-                </a:solidFill>
-                <a:latin typeface="Times New Roman"/>
-              </a:rPr>
-              <a:t>WE FOUND</a:t>
-            </a:r>
-          </a:p>
-        </p:txBody>
-      </p:sp>
-      <p:sp>
-        <p:nvSpPr>
-          <p:cNvPr id="463" name="TextBox 462"/>
+              <a:rPr sz="1400" b="1" i="0">
+                <a:solidFill>
+                  <a:srgbClr val="1C1A17"/>
+                </a:solidFill>
+                <a:latin typeface="Times New Roman"/>
+              </a:rPr>
+              <a:t>Which metrics can explain a single throw</a:t>
+            </a:r>
+          </a:p>
+        </p:txBody>
+      </p:sp>
+      <p:pic>
+        <p:nvPicPr>
+          <p:cNvPr id="200" name="Picture 199" descr="stats_signal_noise.png"/>
+          <p:cNvPicPr>
+            <a:picLocks noChangeAspect="1"/>
+          </p:cNvPicPr>
+          <p:nvPr/>
+        </p:nvPicPr>
+        <p:blipFill>
+          <a:blip r:embed="rId2"/>
+          <a:stretch>
+            <a:fillRect/>
+          </a:stretch>
+        </p:blipFill>
+        <p:spPr>
+          <a:xfrm>
+            <a:off x="1336289" y="2103120"/>
+            <a:ext cx="4139701" cy="2633472"/>
+          </a:xfrm>
+          <a:prstGeom prst="rect">
+            <a:avLst/>
+          </a:prstGeom>
+        </p:spPr>
+      </p:pic>
+      <p:sp>
+        <p:nvSpPr>
+          <p:cNvPr id="201" name="TextBox 200"/>
           <p:cNvSpPr txBox="1"/>
           <p:nvPr/>
         </p:nvSpPr>
         <p:spPr>
           <a:xfrm>
-            <a:off x="4608576" y="2148840"/>
-            <a:ext cx="3017520" cy="640080"/>
+            <a:off x="1005840" y="4773168"/>
+            <a:ext cx="4800600" cy="640080"/>
           </a:xfrm>
           <a:prstGeom prst="rect">
             <a:avLst/>
@@ -22174,109 +22449,31 @@
           <a:p>
             <a:pPr algn="l">
               <a:lnSpc>
-                <a:spcPct val="100000"/>
+                <a:spcPct val="115000"/>
               </a:lnSpc>
             </a:pPr>
             <a:r>
-              <a:rPr sz="3600" b="1" i="0">
-                <a:solidFill>
-                  <a:srgbClr val="8A6A2B"/>
-                </a:solidFill>
-                <a:latin typeface="Times New Roman"/>
-              </a:rPr>
-              <a:t>13 cm</a:t>
-            </a:r>
-          </a:p>
-        </p:txBody>
-      </p:sp>
-      <p:sp>
-        <p:nvSpPr>
-          <p:cNvPr id="464" name="TextBox 463"/>
-          <p:cNvSpPr txBox="1"/>
-          <p:nvPr/>
-        </p:nvSpPr>
-        <p:spPr>
-          <a:xfrm>
-            <a:off x="4608576" y="2816352"/>
-            <a:ext cx="3017520" cy="274320"/>
-          </a:xfrm>
-          <a:prstGeom prst="rect">
-            <a:avLst/>
-          </a:prstGeom>
-          <a:noFill/>
-        </p:spPr>
-        <p:txBody>
-          <a:bodyPr wrap="square" lIns="0" rIns="0" tIns="0" bIns="0" anchor="t">
-            <a:spAutoFit/>
-          </a:bodyPr>
-          <a:lstStyle/>
-          <a:p>
-            <a:pPr algn="l">
-              <a:lnSpc>
-                <a:spcPct val="130000"/>
-              </a:lnSpc>
-            </a:pPr>
-            <a:r>
-              <a:rPr sz="1200" b="0" i="1">
-                <a:solidFill>
-                  <a:srgbClr val="1C1A17"/>
-                </a:solidFill>
-                <a:latin typeface="Times New Roman"/>
-              </a:rPr>
-              <a:t>per 0.1 m/s of release speed</a:t>
-            </a:r>
-          </a:p>
-        </p:txBody>
-      </p:sp>
-      <p:sp>
-        <p:nvSpPr>
-          <p:cNvPr id="465" name="TextBox 464"/>
-          <p:cNvSpPr txBox="1"/>
-          <p:nvPr/>
-        </p:nvSpPr>
-        <p:spPr>
-          <a:xfrm>
-            <a:off x="4608576" y="3246120"/>
-            <a:ext cx="3017520" cy="1463040"/>
-          </a:xfrm>
-          <a:prstGeom prst="rect">
-            <a:avLst/>
-          </a:prstGeom>
-          <a:noFill/>
-        </p:spPr>
-        <p:txBody>
-          <a:bodyPr wrap="square" lIns="0" rIns="0" tIns="0" bIns="0" anchor="t">
-            <a:spAutoFit/>
-          </a:bodyPr>
-          <a:lstStyle/>
-          <a:p>
-            <a:pPr algn="l">
-              <a:lnSpc>
-                <a:spcPct val="130000"/>
-              </a:lnSpc>
-            </a:pPr>
-            <a:r>
-              <a:rPr sz="1200" b="0" i="0">
+              <a:rPr sz="1100" b="0" i="0">
                 <a:solidFill>
                   <a:srgbClr val="57514A"/>
                 </a:solidFill>
                 <a:latin typeface="Times New Roman"/>
               </a:rPr>
-              <a:t>Speed consistency, not angle or power, drives short and long misses; and the slide on the board matters almost as much as the flight.</a:t>
-            </a:r>
-          </a:p>
-        </p:txBody>
-      </p:sp>
-      <p:sp>
-        <p:nvSpPr>
-          <p:cNvPr id="466" name="Rounded Rectangle 465"/>
+              <a:t>Release speed varies almost only within each athlete (ICC 0.01, spread 2.1× its noise): train it. Backswing and trunk lean are stable styles (ICC 0.90–0.96): leave them.</a:t>
+            </a:r>
+          </a:p>
+        </p:txBody>
+      </p:sp>
+      <p:sp>
+        <p:nvSpPr>
+          <p:cNvPr id="202" name="Rounded Rectangle 201"/>
           <p:cNvSpPr/>
           <p:nvPr/>
         </p:nvSpPr>
         <p:spPr>
           <a:xfrm>
-            <a:off x="7991856" y="1691640"/>
-            <a:ext cx="3383280" cy="2971800"/>
+            <a:off x="6208776" y="1691640"/>
+            <a:ext cx="5166360" cy="3749039"/>
           </a:xfrm>
           <a:prstGeom prst="roundRect">
             <a:avLst>
@@ -22315,14 +22512,14 @@
       </p:sp>
       <p:sp>
         <p:nvSpPr>
-          <p:cNvPr id="467" name="TextBox 466"/>
+          <p:cNvPr id="203" name="TextBox 202"/>
           <p:cNvSpPr txBox="1"/>
           <p:nvPr/>
         </p:nvSpPr>
         <p:spPr>
           <a:xfrm>
-            <a:off x="8193024" y="1874519"/>
-            <a:ext cx="3017520" cy="237744"/>
+            <a:off x="6391656" y="1801368"/>
+            <a:ext cx="4800600" cy="237744"/>
           </a:xfrm>
           <a:prstGeom prst="rect">
             <a:avLst/>
@@ -22341,27 +22538,51 @@
               </a:lnSpc>
             </a:pPr>
             <a:r>
-              <a:rPr sz="1200" b="1" i="0">
-                <a:solidFill>
-                  <a:srgbClr val="A8432A"/>
-                </a:solidFill>
-                <a:latin typeface="Times New Roman"/>
-              </a:rPr>
-              <a:t>WHAT COMES NEXT</a:t>
-            </a:r>
-          </a:p>
-        </p:txBody>
-      </p:sp>
-      <p:sp>
-        <p:nvSpPr>
-          <p:cNvPr id="468" name="TextBox 467"/>
+              <a:rPr sz="1400" b="1" i="0">
+                <a:solidFill>
+                  <a:srgbClr val="1C1A17"/>
+                </a:solidFill>
+                <a:latin typeface="Times New Roman"/>
+              </a:rPr>
+              <a:t>Does the body → release → outcome chain show up?</a:t>
+            </a:r>
+          </a:p>
+        </p:txBody>
+      </p:sp>
+      <p:pic>
+        <p:nvPicPr>
+          <p:cNvPr id="204" name="Picture 203" descr="stats_evidence_chain.png"/>
+          <p:cNvPicPr>
+            <a:picLocks noChangeAspect="1"/>
+          </p:cNvPicPr>
+          <p:nvPr/>
+        </p:nvPicPr>
+        <p:blipFill>
+          <a:blip r:embed="rId3"/>
+          <a:stretch>
+            <a:fillRect/>
+          </a:stretch>
+        </p:blipFill>
+        <p:spPr>
+          <a:xfrm>
+            <a:off x="6345936" y="2202082"/>
+            <a:ext cx="4892040" cy="2435548"/>
+          </a:xfrm>
+          <a:prstGeom prst="rect">
+            <a:avLst/>
+          </a:prstGeom>
+        </p:spPr>
+      </p:pic>
+      <p:sp>
+        <p:nvSpPr>
+          <p:cNvPr id="205" name="TextBox 204"/>
           <p:cNvSpPr txBox="1"/>
           <p:nvPr/>
         </p:nvSpPr>
         <p:spPr>
           <a:xfrm>
-            <a:off x="8193024" y="2148840"/>
-            <a:ext cx="3017520" cy="640080"/>
+            <a:off x="6391656" y="4773168"/>
+            <a:ext cx="4800600" cy="640080"/>
           </a:xfrm>
           <a:prstGeom prst="rect">
             <a:avLst/>
@@ -22376,109 +22597,31 @@
           <a:p>
             <a:pPr algn="l">
               <a:lnSpc>
-                <a:spcPct val="100000"/>
+                <a:spcPct val="115000"/>
               </a:lnSpc>
             </a:pPr>
             <a:r>
-              <a:rPr sz="3600" b="1" i="0">
-                <a:solidFill>
-                  <a:srgbClr val="A8432A"/>
-                </a:solidFill>
-                <a:latin typeface="Times New Roman"/>
-              </a:rPr>
-              <a:t>4–6 weeks</a:t>
-            </a:r>
-          </a:p>
-        </p:txBody>
-      </p:sp>
-      <p:sp>
-        <p:nvSpPr>
-          <p:cNvPr id="469" name="TextBox 468"/>
-          <p:cNvSpPr txBox="1"/>
-          <p:nvPr/>
-        </p:nvSpPr>
-        <p:spPr>
-          <a:xfrm>
-            <a:off x="8193024" y="2816352"/>
-            <a:ext cx="3017520" cy="274320"/>
-          </a:xfrm>
-          <a:prstGeom prst="rect">
-            <a:avLst/>
-          </a:prstGeom>
-          <a:noFill/>
-        </p:spPr>
-        <p:txBody>
-          <a:bodyPr wrap="square" lIns="0" rIns="0" tIns="0" bIns="0" anchor="t">
-            <a:spAutoFit/>
-          </a:bodyPr>
-          <a:lstStyle/>
-          <a:p>
-            <a:pPr algn="l">
-              <a:lnSpc>
-                <a:spcPct val="130000"/>
-              </a:lnSpc>
-            </a:pPr>
-            <a:r>
-              <a:rPr sz="1200" b="0" i="1">
-                <a:solidFill>
-                  <a:srgbClr val="1C1A17"/>
-                </a:solidFill>
-                <a:latin typeface="Times New Roman"/>
-              </a:rPr>
-              <a:t>to prove it raises PPR</a:t>
-            </a:r>
-          </a:p>
-        </p:txBody>
-      </p:sp>
-      <p:sp>
-        <p:nvSpPr>
-          <p:cNvPr id="470" name="TextBox 469"/>
-          <p:cNvSpPr txBox="1"/>
-          <p:nvPr/>
-        </p:nvSpPr>
-        <p:spPr>
-          <a:xfrm>
-            <a:off x="8193024" y="3246120"/>
-            <a:ext cx="3017520" cy="1463040"/>
-          </a:xfrm>
-          <a:prstGeom prst="rect">
-            <a:avLst/>
-          </a:prstGeom>
-          <a:noFill/>
-        </p:spPr>
-        <p:txBody>
-          <a:bodyPr wrap="square" lIns="0" rIns="0" tIns="0" bIns="0" anchor="t">
-            <a:spAutoFit/>
-          </a:bodyPr>
-          <a:lstStyle/>
-          <a:p>
-            <a:pPr algn="l">
-              <a:lnSpc>
-                <a:spcPct val="130000"/>
-              </a:lnSpc>
-            </a:pPr>
-            <a:r>
-              <a:rPr sz="1200" b="0" i="0">
+              <a:rPr sz="1100" b="0" i="0">
                 <a:solidFill>
                   <a:srgbClr val="57514A"/>
                 </a:solidFill>
                 <a:latin typeface="Times New Roman"/>
               </a:rPr>
-              <a:t>Alternate weeks with and without app feedback, 40 throws per athlete per week, plus a blinded 20-throw validation check.</a:t>
-            </a:r>
-          </a:p>
-        </p:txBody>
-      </p:sp>
-      <p:sp>
-        <p:nvSpPr>
-          <p:cNvPr id="471" name="Rounded Rectangle 470"/>
+              <a:t>Release angle → apex height is clear for all four (ρ 0.80–0.97). No release value predicts points yet at 20–28 throws each: an honest null, not a hidden effect.</a:t>
+            </a:r>
+          </a:p>
+        </p:txBody>
+      </p:sp>
+      <p:sp>
+        <p:nvSpPr>
+          <p:cNvPr id="206" name="Rounded Rectangle 205"/>
           <p:cNvSpPr/>
           <p:nvPr/>
         </p:nvSpPr>
         <p:spPr>
           <a:xfrm>
-            <a:off x="822960" y="4983480"/>
-            <a:ext cx="10552176" cy="868680"/>
+            <a:off x="822960" y="5532120"/>
+            <a:ext cx="10552176" cy="548640"/>
           </a:xfrm>
           <a:prstGeom prst="roundRect">
             <a:avLst>
@@ -22515,14 +22658,14 @@
       </p:sp>
       <p:sp>
         <p:nvSpPr>
-          <p:cNvPr id="472" name="TextBox 471"/>
+          <p:cNvPr id="207" name="TextBox 206"/>
           <p:cNvSpPr txBox="1"/>
           <p:nvPr/>
         </p:nvSpPr>
         <p:spPr>
           <a:xfrm>
-            <a:off x="1051560" y="4983480"/>
-            <a:ext cx="1828800" cy="868680"/>
+            <a:off x="1005840" y="5532120"/>
+            <a:ext cx="10241280" cy="548640"/>
           </a:xfrm>
           <a:prstGeom prst="rect">
             <a:avLst/>
@@ -22537,56 +22680,26 @@
           <a:p>
             <a:pPr algn="l">
               <a:lnSpc>
-                <a:spcPct val="130000"/>
+                <a:spcPct val="115000"/>
               </a:lnSpc>
             </a:pPr>
             <a:r>
-              <a:rPr sz="1200" b="1" i="0">
+              <a:rPr sz="1150" b="1" i="0">
                 <a:solidFill>
                   <a:srgbClr val="C9A45C"/>
                 </a:solidFill>
                 <a:latin typeface="Times New Roman"/>
               </a:rPr>
-              <a:t>TAKE-HOME</a:t>
-            </a:r>
-          </a:p>
-        </p:txBody>
-      </p:sp>
-      <p:sp>
-        <p:nvSpPr>
-          <p:cNvPr id="473" name="TextBox 472"/>
-          <p:cNvSpPr txBox="1"/>
-          <p:nvPr/>
-        </p:nvSpPr>
-        <p:spPr>
-          <a:xfrm>
-            <a:off x="2743200" y="4983480"/>
-            <a:ext cx="8503920" cy="868680"/>
-          </a:xfrm>
-          <a:prstGeom prst="rect">
-            <a:avLst/>
-          </a:prstGeom>
-          <a:noFill/>
-        </p:spPr>
-        <p:txBody>
-          <a:bodyPr wrap="square" lIns="0" rIns="0" tIns="0" bIns="0" anchor="ctr">
-            <a:spAutoFit/>
-          </a:bodyPr>
-          <a:lstStyle/>
-          <a:p>
-            <a:pPr algn="l">
-              <a:lnSpc>
-                <a:spcPct val="130000"/>
-              </a:lnSpc>
-            </a:pPr>
-            <a:r>
-              <a:rPr sz="1800" b="0" i="1">
+              <a:t>Evidence gate. </a:t>
+            </a:r>
+            <a:r>
+              <a:rPr sz="1150" b="0" i="0">
                 <a:solidFill>
                   <a:srgbClr val="FFFFFF"/>
                 </a:solidFill>
                 <a:latin typeface="Times New Roman"/>
               </a:rPr>
-              <a:t>Measure the throw. Explain the miss. Coach only what the data supports.</a:t>
+              <a:t>A body cue reaches the coach only with ≥ 5 throws per group, Cliff's |δ| above the Bonferroni chance level (never below 0.474), a difference larger than the noise floor, and a bootstrap 95% CI that excludes 0.</a:t>
             </a:r>
           </a:p>
         </p:txBody>
@@ -22675,7 +22788,7 @@
                 <a:cs typeface="Times New Roman"/>
                 <a:sym typeface="Times New Roman"/>
               </a:rPr>
-              <a:t>OUR TALK</a:t>
+              <a:t>BACKUP · OUR TALK</a:t>
             </a:r>
             <a:endParaRPr b="0" i="0" sz="1200" u="none" cap="none" strike="noStrike">
               <a:solidFill>
@@ -24481,7 +24594,7 @@
                 <a:cs typeface="Times New Roman"/>
                 <a:sym typeface="Times New Roman"/>
               </a:rPr>
-              <a:t>Emily Park · 2 / 17</a:t>
+              <a:t>Emily Park · backup</a:t>
             </a:r>
             <a:endParaRPr b="0" i="0" sz="1200" u="none" cap="none" strike="noStrike">
               <a:solidFill>
@@ -24492,6 +24605,2357 @@
               <a:cs typeface="Times New Roman"/>
               <a:sym typeface="Times New Roman"/>
             </a:endParaRPr>
+          </a:p>
+        </p:txBody>
+      </p:sp>
+    </p:spTree>
+  </p:cSld>
+  <p:clrMapOvr>
+    <a:masterClrMapping/>
+  </p:clrMapOvr>
+</p:sld>
+</file>
+
+<file path=ppt/slides/slide20.xml><?xml version="1.0" encoding="utf-8"?>
+<p:sld xmlns:a="http://schemas.openxmlformats.org/drawingml/2006/main" xmlns:p="http://schemas.openxmlformats.org/presentationml/2006/main" xmlns:r="http://schemas.openxmlformats.org/officeDocument/2006/relationships">
+  <p:cSld>
+    <p:bg>
+      <p:bgPr>
+        <a:solidFill>
+          <a:srgbClr val="FAF8F3"/>
+        </a:solidFill>
+      </p:bgPr>
+    </p:bg>
+    <p:spTree>
+      <p:nvGrpSpPr>
+        <p:cNvPr id="1" name=""/>
+        <p:cNvGrpSpPr/>
+        <p:nvPr/>
+      </p:nvGrpSpPr>
+      <p:grpSpPr/>
+      <p:sp>
+        <p:nvSpPr>
+          <p:cNvPr id="363" name="Google Shape;363;p13"/>
+          <p:cNvSpPr/>
+          <p:nvPr/>
+        </p:nvSpPr>
+        <p:spPr>
+          <a:xfrm>
+            <a:off x="812800" y="812800"/>
+            <a:ext cx="10883392" cy="238720"/>
+          </a:xfrm>
+          <a:prstGeom prst="rect">
+            <a:avLst/>
+          </a:prstGeom>
+          <a:noFill/>
+          <a:ln>
+            <a:noFill/>
+          </a:ln>
+        </p:spPr>
+        <p:txBody>
+          <a:bodyPr anchorCtr="0" anchor="t" bIns="0" lIns="0" spcFirstLastPara="1" rIns="0" wrap="square" tIns="0">
+            <a:normAutofit/>
+          </a:bodyPr>
+          <a:lstStyle/>
+          <a:p>
+            <a:pPr indent="0" lvl="0" marL="0" marR="0" rtl="0" algn="l">
+              <a:lnSpc>
+                <a:spcPct val="140000"/>
+              </a:lnSpc>
+              <a:spcBef>
+                <a:spcPts val="0"/>
+              </a:spcBef>
+              <a:spcAft>
+                <a:spcPts val="0"/>
+              </a:spcAft>
+              <a:buClr>
+                <a:srgbClr val="8A6A2B"/>
+              </a:buClr>
+              <a:buSzPts val="1200"/>
+              <a:buFont typeface="Times New Roman"/>
+              <a:buNone/>
+            </a:pPr>
+            <a:r>
+              <a:rPr b="1" i="0" lang="en-US" spc="100" sz="1200" u="none" cap="none" strike="noStrike">
+                <a:solidFill>
+                  <a:srgbClr val="8A6A2B"/>
+                </a:solidFill>
+                <a:latin typeface="Times New Roman"/>
+                <a:ea typeface="Times New Roman"/>
+                <a:cs typeface="Times New Roman"/>
+                <a:sym typeface="Times New Roman"/>
+              </a:rPr>
+              <a:t>PART 4 · WHERE THE 92 THROWS WENT</a:t>
+            </a:r>
+            <a:endParaRPr b="0" i="0" sz="1200" u="none" cap="none" strike="noStrike">
+              <a:solidFill>
+                <a:schemeClr val="dk1"/>
+              </a:solidFill>
+              <a:latin typeface="Times New Roman"/>
+              <a:ea typeface="Times New Roman"/>
+              <a:cs typeface="Times New Roman"/>
+              <a:sym typeface="Times New Roman"/>
+            </a:endParaRPr>
+          </a:p>
+        </p:txBody>
+      </p:sp>
+      <p:sp>
+        <p:nvSpPr>
+          <p:cNvPr id="364" name="Google Shape;364;p13"/>
+          <p:cNvSpPr txBox="1"/>
+          <p:nvPr>
+            <p:ph type="title"/>
+          </p:nvPr>
+        </p:nvSpPr>
+        <p:spPr>
+          <a:xfrm>
+            <a:off x="812800" y="1102320"/>
+            <a:ext cx="10883392" cy="444500"/>
+          </a:xfrm>
+          <a:prstGeom prst="rect">
+            <a:avLst/>
+          </a:prstGeom>
+          <a:noFill/>
+          <a:ln>
+            <a:noFill/>
+          </a:ln>
+        </p:spPr>
+        <p:txBody>
+          <a:bodyPr anchorCtr="0" anchor="t" bIns="0" lIns="0" spcFirstLastPara="1" rIns="0" wrap="square" tIns="0">
+            <a:normAutofit/>
+          </a:bodyPr>
+          <a:lstStyle/>
+          <a:p>
+            <a:pPr indent="0" lvl="0" marL="0" rtl="0" algn="l">
+              <a:lnSpc>
+                <a:spcPct val="110000"/>
+              </a:lnSpc>
+              <a:spcBef>
+                <a:spcPts val="0"/>
+              </a:spcBef>
+              <a:spcAft>
+                <a:spcPts val="0"/>
+              </a:spcAft>
+              <a:buClr>
+                <a:srgbClr val="1C1A17"/>
+              </a:buClr>
+              <a:buSzPts val="3000"/>
+              <a:buFont typeface="Times New Roman"/>
+              <a:buNone/>
+            </a:pPr>
+            <a:r>
+              <a:rPr b="1" i="0" lang="en-US" sz="3000">
+                <a:solidFill>
+                  <a:srgbClr val="1C1A17"/>
+                </a:solidFill>
+                <a:latin typeface="Times New Roman"/>
+                <a:ea typeface="Times New Roman"/>
+                <a:cs typeface="Times New Roman"/>
+                <a:sym typeface="Times New Roman"/>
+              </a:rPr>
+              <a:t>Same release, very different results</a:t>
+            </a:r>
+            <a:endParaRPr sz="3000"/>
+          </a:p>
+        </p:txBody>
+      </p:sp>
+      <p:sp>
+        <p:nvSpPr>
+          <p:cNvPr id="392" name="Google Shape;392;p13"/>
+          <p:cNvSpPr/>
+          <p:nvPr/>
+        </p:nvSpPr>
+        <p:spPr>
+          <a:xfrm>
+            <a:off x="812800" y="6238280"/>
+            <a:ext cx="2092404" cy="238720"/>
+          </a:xfrm>
+          <a:prstGeom prst="rect">
+            <a:avLst/>
+          </a:prstGeom>
+          <a:noFill/>
+          <a:ln>
+            <a:noFill/>
+          </a:ln>
+        </p:spPr>
+        <p:txBody>
+          <a:bodyPr anchorCtr="0" anchor="t" bIns="0" lIns="0" spcFirstLastPara="1" rIns="0" wrap="square" tIns="0">
+            <a:normAutofit/>
+          </a:bodyPr>
+          <a:lstStyle/>
+          <a:p>
+            <a:pPr indent="0" lvl="0" marL="0" marR="0" rtl="0" algn="l">
+              <a:lnSpc>
+                <a:spcPct val="140000"/>
+              </a:lnSpc>
+              <a:spcBef>
+                <a:spcPts val="0"/>
+              </a:spcBef>
+              <a:spcAft>
+                <a:spcPts val="0"/>
+              </a:spcAft>
+              <a:buClr>
+                <a:srgbClr val="6E665C"/>
+              </a:buClr>
+              <a:buSzPts val="1200"/>
+              <a:buFont typeface="Times New Roman"/>
+              <a:buNone/>
+            </a:pPr>
+            <a:r>
+              <a:rPr b="0" i="0" lang="en-US" sz="1200" u="none" cap="none" strike="noStrike">
+                <a:solidFill>
+                  <a:srgbClr val="6E665C"/>
+                </a:solidFill>
+                <a:latin typeface="Times New Roman"/>
+                <a:ea typeface="Times New Roman"/>
+                <a:cs typeface="Times New Roman"/>
+                <a:sym typeface="Times New Roman"/>
+              </a:rPr>
+              <a:t>Cornhole Biomechanics Lab</a:t>
+            </a:r>
+            <a:endParaRPr b="0" i="0" sz="1200" u="none" cap="none" strike="noStrike">
+              <a:solidFill>
+                <a:schemeClr val="dk1"/>
+              </a:solidFill>
+              <a:latin typeface="Times New Roman"/>
+              <a:ea typeface="Times New Roman"/>
+              <a:cs typeface="Times New Roman"/>
+              <a:sym typeface="Times New Roman"/>
+            </a:endParaRPr>
+          </a:p>
+        </p:txBody>
+      </p:sp>
+      <p:sp>
+        <p:nvSpPr>
+          <p:cNvPr id="393" name="Google Shape;393;p13"/>
+          <p:cNvSpPr/>
+          <p:nvPr/>
+        </p:nvSpPr>
+        <p:spPr>
+          <a:xfrm>
+            <a:off x="9758878" y="6238280"/>
+            <a:ext cx="1620322" cy="238720"/>
+          </a:xfrm>
+          <a:prstGeom prst="rect">
+            <a:avLst/>
+          </a:prstGeom>
+          <a:noFill/>
+          <a:ln>
+            <a:noFill/>
+          </a:ln>
+        </p:spPr>
+        <p:txBody>
+          <a:bodyPr anchorCtr="0" anchor="t" bIns="0" lIns="0" spcFirstLastPara="1" rIns="0" wrap="square" tIns="0">
+            <a:normAutofit/>
+          </a:bodyPr>
+          <a:lstStyle/>
+          <a:p>
+            <a:pPr indent="0" lvl="0" marL="0" marR="0" rtl="0" algn="r">
+              <a:lnSpc>
+                <a:spcPct val="140000"/>
+              </a:lnSpc>
+              <a:spcBef>
+                <a:spcPts val="0"/>
+              </a:spcBef>
+              <a:spcAft>
+                <a:spcPts val="0"/>
+              </a:spcAft>
+              <a:buClr>
+                <a:srgbClr val="6E665C"/>
+              </a:buClr>
+              <a:buSzPts val="1200"/>
+              <a:buFont typeface="Times New Roman"/>
+              <a:buNone/>
+            </a:pPr>
+            <a:r>
+              <a:rPr b="0" i="0" lang="en-US" sz="1200" u="none" cap="none" strike="noStrike">
+                <a:solidFill>
+                  <a:srgbClr val="6E665C"/>
+                </a:solidFill>
+                <a:latin typeface="Times New Roman"/>
+                <a:ea typeface="Times New Roman"/>
+                <a:cs typeface="Times New Roman"/>
+                <a:sym typeface="Times New Roman"/>
+              </a:rPr>
+              <a:t>Eliam Chang · 10 / 12</a:t>
+            </a:r>
+            <a:endParaRPr b="0" i="0" sz="1200" u="none" cap="none" strike="noStrike">
+              <a:solidFill>
+                <a:schemeClr val="dk1"/>
+              </a:solidFill>
+              <a:latin typeface="Times New Roman"/>
+              <a:ea typeface="Times New Roman"/>
+              <a:cs typeface="Times New Roman"/>
+              <a:sym typeface="Times New Roman"/>
+            </a:endParaRPr>
+          </a:p>
+        </p:txBody>
+      </p:sp>
+      <p:sp>
+        <p:nvSpPr>
+          <p:cNvPr id="394" name="Rounded Rectangle 393"/>
+          <p:cNvSpPr/>
+          <p:nvPr/>
+        </p:nvSpPr>
+        <p:spPr>
+          <a:xfrm>
+            <a:off x="822960" y="1600200"/>
+            <a:ext cx="3017520" cy="4434840"/>
+          </a:xfrm>
+          <a:prstGeom prst="roundRect">
+            <a:avLst>
+              <a:gd name="adj" fmla="val 2000"/>
+            </a:avLst>
+          </a:prstGeom>
+          <a:solidFill>
+            <a:srgbClr val="FFFEFB"/>
+          </a:solidFill>
+          <a:ln w="12700">
+            <a:solidFill>
+              <a:srgbClr val="E3DCCF"/>
+            </a:solidFill>
+          </a:ln>
+          <a:effectLst/>
+        </p:spPr>
+        <p:style>
+          <a:lnRef idx="1">
+            <a:schemeClr val="accent1"/>
+          </a:lnRef>
+          <a:fillRef idx="3">
+            <a:schemeClr val="accent1"/>
+          </a:fillRef>
+          <a:effectRef idx="2">
+            <a:schemeClr val="accent1"/>
+          </a:effectRef>
+          <a:fontRef idx="minor">
+            <a:schemeClr val="lt1"/>
+          </a:fontRef>
+        </p:style>
+        <p:txBody>
+          <a:bodyPr rtlCol="0" anchor="ctr"/>
+          <a:lstStyle/>
+          <a:p/>
+        </p:txBody>
+      </p:sp>
+      <p:sp>
+        <p:nvSpPr>
+          <p:cNvPr id="395" name="TextBox 394"/>
+          <p:cNvSpPr txBox="1"/>
+          <p:nvPr/>
+        </p:nvSpPr>
+        <p:spPr>
+          <a:xfrm>
+            <a:off x="1005840" y="1755648"/>
+            <a:ext cx="2697480" cy="237744"/>
+          </a:xfrm>
+          <a:prstGeom prst="rect">
+            <a:avLst/>
+          </a:prstGeom>
+          <a:noFill/>
+        </p:spPr>
+        <p:txBody>
+          <a:bodyPr wrap="square" lIns="0" rIns="0" tIns="0" bIns="0" anchor="t">
+            <a:spAutoFit/>
+          </a:bodyPr>
+          <a:lstStyle/>
+          <a:p>
+            <a:pPr algn="l">
+              <a:lnSpc>
+                <a:spcPct val="130000"/>
+              </a:lnSpc>
+            </a:pPr>
+            <a:r>
+              <a:rPr sz="1400" b="1" i="0">
+                <a:solidFill>
+                  <a:srgbClr val="1C1A17"/>
+                </a:solidFill>
+                <a:latin typeface="Times New Roman"/>
+              </a:rPr>
+              <a:t>First contact on the board</a:t>
+            </a:r>
+          </a:p>
+        </p:txBody>
+      </p:sp>
+      <p:sp>
+        <p:nvSpPr>
+          <p:cNvPr id="396" name="TextBox 395"/>
+          <p:cNvSpPr txBox="1"/>
+          <p:nvPr/>
+        </p:nvSpPr>
+        <p:spPr>
+          <a:xfrm>
+            <a:off x="1005840" y="2011680"/>
+            <a:ext cx="2697480" cy="365760"/>
+          </a:xfrm>
+          <a:prstGeom prst="rect">
+            <a:avLst/>
+          </a:prstGeom>
+          <a:noFill/>
+        </p:spPr>
+        <p:txBody>
+          <a:bodyPr wrap="square" lIns="0" rIns="0" tIns="0" bIns="0" anchor="t">
+            <a:spAutoFit/>
+          </a:bodyPr>
+          <a:lstStyle/>
+          <a:p>
+            <a:pPr algn="l">
+              <a:lnSpc>
+                <a:spcPct val="130000"/>
+              </a:lnSpc>
+            </a:pPr>
+            <a:r>
+              <a:rPr sz="1100" b="0" i="0">
+                <a:solidFill>
+                  <a:srgbClr val="57514A"/>
+                </a:solidFill>
+                <a:latin typeface="Times New Roman"/>
+              </a:rPr>
+              <a:t>Each dot is where a bag first touched (81 located).</a:t>
+            </a:r>
+          </a:p>
+        </p:txBody>
+      </p:sp>
+      <p:pic>
+        <p:nvPicPr>
+          <p:cNvPr id="397" name="Picture 396" descr="landing_map.png"/>
+          <p:cNvPicPr>
+            <a:picLocks noChangeAspect="1"/>
+          </p:cNvPicPr>
+          <p:nvPr/>
+        </p:nvPicPr>
+        <p:blipFill>
+          <a:blip r:embed="rId2"/>
+          <a:stretch>
+            <a:fillRect/>
+          </a:stretch>
+        </p:blipFill>
+        <p:spPr>
+          <a:xfrm>
+            <a:off x="1097280" y="2395728"/>
+            <a:ext cx="2559589" cy="2834640"/>
+          </a:xfrm>
+          <a:prstGeom prst="rect">
+            <a:avLst/>
+          </a:prstGeom>
+        </p:spPr>
+      </p:pic>
+      <p:sp>
+        <p:nvSpPr>
+          <p:cNvPr id="398" name="TextBox 397"/>
+          <p:cNvSpPr txBox="1"/>
+          <p:nvPr/>
+        </p:nvSpPr>
+        <p:spPr>
+          <a:xfrm>
+            <a:off x="1005840" y="5303520"/>
+            <a:ext cx="2697480" cy="640080"/>
+          </a:xfrm>
+          <a:prstGeom prst="rect">
+            <a:avLst/>
+          </a:prstGeom>
+          <a:noFill/>
+        </p:spPr>
+        <p:txBody>
+          <a:bodyPr wrap="square" lIns="0" rIns="0" tIns="0" bIns="0" anchor="t">
+            <a:spAutoFit/>
+          </a:bodyPr>
+          <a:lstStyle/>
+          <a:p>
+            <a:pPr algn="l">
+              <a:lnSpc>
+                <a:spcPct val="130000"/>
+              </a:lnSpc>
+            </a:pPr>
+            <a:r>
+              <a:rPr sz="1200" b="1" i="0">
+                <a:solidFill>
+                  <a:srgbClr val="2F5D8A"/>
+                </a:solidFill>
+                <a:latin typeface="Times New Roman"/>
+              </a:rPr>
+              <a:t>Hole shots land about 18 in short and slide in.</a:t>
+            </a:r>
+          </a:p>
+        </p:txBody>
+      </p:sp>
+      <p:sp>
+        <p:nvSpPr>
+          <p:cNvPr id="399" name="Rounded Rectangle 398"/>
+          <p:cNvSpPr/>
+          <p:nvPr/>
+        </p:nvSpPr>
+        <p:spPr>
+          <a:xfrm>
+            <a:off x="4023360" y="1600200"/>
+            <a:ext cx="7351775" cy="2148840"/>
+          </a:xfrm>
+          <a:prstGeom prst="roundRect">
+            <a:avLst>
+              <a:gd name="adj" fmla="val 2000"/>
+            </a:avLst>
+          </a:prstGeom>
+          <a:solidFill>
+            <a:srgbClr val="FFFEFB"/>
+          </a:solidFill>
+          <a:ln w="12700">
+            <a:solidFill>
+              <a:srgbClr val="E3DCCF"/>
+            </a:solidFill>
+          </a:ln>
+          <a:effectLst/>
+        </p:spPr>
+        <p:style>
+          <a:lnRef idx="1">
+            <a:schemeClr val="accent1"/>
+          </a:lnRef>
+          <a:fillRef idx="3">
+            <a:schemeClr val="accent1"/>
+          </a:fillRef>
+          <a:effectRef idx="2">
+            <a:schemeClr val="accent1"/>
+          </a:effectRef>
+          <a:fontRef idx="minor">
+            <a:schemeClr val="lt1"/>
+          </a:fontRef>
+        </p:style>
+        <p:txBody>
+          <a:bodyPr rtlCol="0" anchor="ctr"/>
+          <a:lstStyle/>
+          <a:p/>
+        </p:txBody>
+      </p:sp>
+      <p:pic>
+        <p:nvPicPr>
+          <p:cNvPr id="400" name="Picture 399" descr="outcomes_by_athlete.png"/>
+          <p:cNvPicPr>
+            <a:picLocks noChangeAspect="1"/>
+          </p:cNvPicPr>
+          <p:nvPr/>
+        </p:nvPicPr>
+        <p:blipFill>
+          <a:blip r:embed="rId3"/>
+          <a:stretch>
+            <a:fillRect/>
+          </a:stretch>
+        </p:blipFill>
+        <p:spPr>
+          <a:xfrm>
+            <a:off x="4160520" y="1719072"/>
+            <a:ext cx="3925827" cy="1874519"/>
+          </a:xfrm>
+          <a:prstGeom prst="rect">
+            <a:avLst/>
+          </a:prstGeom>
+        </p:spPr>
+      </p:pic>
+      <p:sp>
+        <p:nvSpPr>
+          <p:cNvPr id="401" name="TextBox 400"/>
+          <p:cNvSpPr txBox="1"/>
+          <p:nvPr/>
+        </p:nvSpPr>
+        <p:spPr>
+          <a:xfrm>
+            <a:off x="8458200" y="1755648"/>
+            <a:ext cx="2788920" cy="237744"/>
+          </a:xfrm>
+          <a:prstGeom prst="rect">
+            <a:avLst/>
+          </a:prstGeom>
+          <a:noFill/>
+        </p:spPr>
+        <p:txBody>
+          <a:bodyPr wrap="square" lIns="0" rIns="0" tIns="0" bIns="0" anchor="t">
+            <a:spAutoFit/>
+          </a:bodyPr>
+          <a:lstStyle/>
+          <a:p>
+            <a:pPr algn="l">
+              <a:lnSpc>
+                <a:spcPct val="130000"/>
+              </a:lnSpc>
+            </a:pPr>
+            <a:r>
+              <a:rPr sz="1400" b="1" i="0">
+                <a:solidFill>
+                  <a:srgbClr val="1C1A17"/>
+                </a:solidFill>
+                <a:latin typeface="Times New Roman"/>
+              </a:rPr>
+              <a:t>Outcome per athlete</a:t>
+            </a:r>
+          </a:p>
+        </p:txBody>
+      </p:sp>
+      <p:sp>
+        <p:nvSpPr>
+          <p:cNvPr id="402" name="TextBox 401"/>
+          <p:cNvSpPr txBox="1"/>
+          <p:nvPr/>
+        </p:nvSpPr>
+        <p:spPr>
+          <a:xfrm>
+            <a:off x="8458200" y="2029968"/>
+            <a:ext cx="2788920" cy="1097280"/>
+          </a:xfrm>
+          <a:prstGeom prst="rect">
+            <a:avLst/>
+          </a:prstGeom>
+          <a:noFill/>
+        </p:spPr>
+        <p:txBody>
+          <a:bodyPr wrap="square" lIns="0" rIns="0" tIns="0" bIns="0" anchor="t">
+            <a:spAutoFit/>
+          </a:bodyPr>
+          <a:lstStyle/>
+          <a:p>
+            <a:pPr algn="l">
+              <a:lnSpc>
+                <a:spcPct val="130000"/>
+              </a:lnSpc>
+            </a:pPr>
+            <a:r>
+              <a:rPr sz="1200" b="0" i="0">
+                <a:solidFill>
+                  <a:srgbClr val="57514A"/>
+                </a:solidFill>
+                <a:latin typeface="Times New Roman"/>
+              </a:rPr>
+              <a:t>18 hole · 38 board · 36 off. All four release near 7.5 m/s, yet PPR runs from 1.4 to 6.0.</a:t>
+            </a:r>
+          </a:p>
+        </p:txBody>
+      </p:sp>
+      <p:sp>
+        <p:nvSpPr>
+          <p:cNvPr id="403" name="TextBox 402"/>
+          <p:cNvSpPr txBox="1"/>
+          <p:nvPr/>
+        </p:nvSpPr>
+        <p:spPr>
+          <a:xfrm>
+            <a:off x="8458200" y="3154680"/>
+            <a:ext cx="2788920" cy="457200"/>
+          </a:xfrm>
+          <a:prstGeom prst="rect">
+            <a:avLst/>
+          </a:prstGeom>
+          <a:noFill/>
+        </p:spPr>
+        <p:txBody>
+          <a:bodyPr wrap="square" lIns="0" rIns="0" tIns="0" bIns="0" anchor="t">
+            <a:spAutoFit/>
+          </a:bodyPr>
+          <a:lstStyle/>
+          <a:p>
+            <a:pPr algn="l">
+              <a:lnSpc>
+                <a:spcPct val="130000"/>
+              </a:lnSpc>
+            </a:pPr>
+            <a:r>
+              <a:rPr sz="1200" b="1" i="0">
+                <a:solidFill>
+                  <a:srgbClr val="2F5D8A"/>
+                </a:solidFill>
+                <a:latin typeface="Times New Roman"/>
+              </a:rPr>
+              <a:t>→ Consistency, not power, sets the score.</a:t>
+            </a:r>
+          </a:p>
+        </p:txBody>
+      </p:sp>
+      <p:sp>
+        <p:nvSpPr>
+          <p:cNvPr id="404" name="Rounded Rectangle 403"/>
+          <p:cNvSpPr/>
+          <p:nvPr/>
+        </p:nvSpPr>
+        <p:spPr>
+          <a:xfrm>
+            <a:off x="4023360" y="3886200"/>
+            <a:ext cx="7351775" cy="2148840"/>
+          </a:xfrm>
+          <a:prstGeom prst="roundRect">
+            <a:avLst>
+              <a:gd name="adj" fmla="val 2000"/>
+            </a:avLst>
+          </a:prstGeom>
+          <a:solidFill>
+            <a:srgbClr val="FFFEFB"/>
+          </a:solidFill>
+          <a:ln w="12700">
+            <a:solidFill>
+              <a:srgbClr val="E3DCCF"/>
+            </a:solidFill>
+          </a:ln>
+          <a:effectLst/>
+        </p:spPr>
+        <p:style>
+          <a:lnRef idx="1">
+            <a:schemeClr val="accent1"/>
+          </a:lnRef>
+          <a:fillRef idx="3">
+            <a:schemeClr val="accent1"/>
+          </a:fillRef>
+          <a:effectRef idx="2">
+            <a:schemeClr val="accent1"/>
+          </a:effectRef>
+          <a:fontRef idx="minor">
+            <a:schemeClr val="lt1"/>
+          </a:fontRef>
+        </p:style>
+        <p:txBody>
+          <a:bodyPr rtlCol="0" anchor="ctr"/>
+          <a:lstStyle/>
+          <a:p/>
+        </p:txBody>
+      </p:sp>
+      <p:pic>
+        <p:nvPicPr>
+          <p:cNvPr id="405" name="Picture 404" descr="miss_causes.png"/>
+          <p:cNvPicPr>
+            <a:picLocks noChangeAspect="1"/>
+          </p:cNvPicPr>
+          <p:nvPr/>
+        </p:nvPicPr>
+        <p:blipFill>
+          <a:blip r:embed="rId4"/>
+          <a:stretch>
+            <a:fillRect/>
+          </a:stretch>
+        </p:blipFill>
+        <p:spPr>
+          <a:xfrm>
+            <a:off x="4160520" y="3995928"/>
+            <a:ext cx="3758032" cy="1920240"/>
+          </a:xfrm>
+          <a:prstGeom prst="rect">
+            <a:avLst/>
+          </a:prstGeom>
+        </p:spPr>
+      </p:pic>
+      <p:sp>
+        <p:nvSpPr>
+          <p:cNvPr id="406" name="TextBox 405"/>
+          <p:cNvSpPr txBox="1"/>
+          <p:nvPr/>
+        </p:nvSpPr>
+        <p:spPr>
+          <a:xfrm>
+            <a:off x="8458200" y="4041648"/>
+            <a:ext cx="2788920" cy="237744"/>
+          </a:xfrm>
+          <a:prstGeom prst="rect">
+            <a:avLst/>
+          </a:prstGeom>
+          <a:noFill/>
+        </p:spPr>
+        <p:txBody>
+          <a:bodyPr wrap="square" lIns="0" rIns="0" tIns="0" bIns="0" anchor="t">
+            <a:spAutoFit/>
+          </a:bodyPr>
+          <a:lstStyle/>
+          <a:p>
+            <a:pPr algn="l">
+              <a:lnSpc>
+                <a:spcPct val="130000"/>
+              </a:lnSpc>
+            </a:pPr>
+            <a:r>
+              <a:rPr sz="1400" b="1" i="0">
+                <a:solidFill>
+                  <a:srgbClr val="1C1A17"/>
+                </a:solidFill>
+                <a:latin typeface="Times New Roman"/>
+              </a:rPr>
+              <a:t>What each miss came from</a:t>
+            </a:r>
+          </a:p>
+        </p:txBody>
+      </p:sp>
+      <p:sp>
+        <p:nvSpPr>
+          <p:cNvPr id="407" name="TextBox 406"/>
+          <p:cNvSpPr txBox="1"/>
+          <p:nvPr/>
+        </p:nvSpPr>
+        <p:spPr>
+          <a:xfrm>
+            <a:off x="8458200" y="4315968"/>
+            <a:ext cx="2788920" cy="1097280"/>
+          </a:xfrm>
+          <a:prstGeom prst="rect">
+            <a:avLst/>
+          </a:prstGeom>
+          <a:noFill/>
+        </p:spPr>
+        <p:txBody>
+          <a:bodyPr wrap="square" lIns="0" rIns="0" tIns="0" bIns="0" anchor="t">
+            <a:spAutoFit/>
+          </a:bodyPr>
+          <a:lstStyle/>
+          <a:p>
+            <a:pPr algn="l">
+              <a:lnSpc>
+                <a:spcPct val="130000"/>
+              </a:lnSpc>
+            </a:pPr>
+            <a:r>
+              <a:rPr sz="1200" b="0" i="0">
+                <a:solidFill>
+                  <a:srgbClr val="57514A"/>
+                </a:solidFill>
+                <a:latin typeface="Times New Roman"/>
+              </a:rPr>
+              <a:t>Parts the app named above noise in 44 misses. The flight (39) and the slide on the board (31) are close.</a:t>
+            </a:r>
+          </a:p>
+        </p:txBody>
+      </p:sp>
+      <p:sp>
+        <p:nvSpPr>
+          <p:cNvPr id="408" name="TextBox 407"/>
+          <p:cNvSpPr txBox="1"/>
+          <p:nvPr/>
+        </p:nvSpPr>
+        <p:spPr>
+          <a:xfrm>
+            <a:off x="8458200" y="5440680"/>
+            <a:ext cx="2788920" cy="457200"/>
+          </a:xfrm>
+          <a:prstGeom prst="rect">
+            <a:avLst/>
+          </a:prstGeom>
+          <a:noFill/>
+        </p:spPr>
+        <p:txBody>
+          <a:bodyPr wrap="square" lIns="0" rIns="0" tIns="0" bIns="0" anchor="t">
+            <a:spAutoFit/>
+          </a:bodyPr>
+          <a:lstStyle/>
+          <a:p>
+            <a:pPr algn="l">
+              <a:lnSpc>
+                <a:spcPct val="130000"/>
+              </a:lnSpc>
+            </a:pPr>
+            <a:r>
+              <a:rPr sz="1200" b="1" i="0">
+                <a:solidFill>
+                  <a:srgbClr val="A8432A"/>
+                </a:solidFill>
+                <a:latin typeface="Times New Roman"/>
+              </a:rPr>
+              <a:t>→ Train board feel, not only the arm.</a:t>
+            </a:r>
+          </a:p>
+        </p:txBody>
+      </p:sp>
+    </p:spTree>
+  </p:cSld>
+  <p:clrMapOvr>
+    <a:masterClrMapping/>
+  </p:clrMapOvr>
+</p:sld>
+</file>
+
+<file path=ppt/slides/slide21.xml><?xml version="1.0" encoding="utf-8"?>
+<p:sld xmlns:a="http://schemas.openxmlformats.org/drawingml/2006/main" xmlns:p="http://schemas.openxmlformats.org/presentationml/2006/main" xmlns:r="http://schemas.openxmlformats.org/officeDocument/2006/relationships">
+  <p:cSld>
+    <p:bg>
+      <p:bgPr>
+        <a:solidFill>
+          <a:srgbClr val="FAF8F3"/>
+        </a:solidFill>
+      </p:bgPr>
+    </p:bg>
+    <p:spTree>
+      <p:nvGrpSpPr>
+        <p:cNvPr id="1" name=""/>
+        <p:cNvGrpSpPr/>
+        <p:nvPr/>
+      </p:nvGrpSpPr>
+      <p:grpSpPr/>
+      <p:sp>
+        <p:nvSpPr>
+          <p:cNvPr id="426" name="Google Shape;426;p15"/>
+          <p:cNvSpPr/>
+          <p:nvPr/>
+        </p:nvSpPr>
+        <p:spPr>
+          <a:xfrm>
+            <a:off x="812800" y="812800"/>
+            <a:ext cx="10883392" cy="238720"/>
+          </a:xfrm>
+          <a:prstGeom prst="rect">
+            <a:avLst/>
+          </a:prstGeom>
+          <a:noFill/>
+          <a:ln>
+            <a:noFill/>
+          </a:ln>
+        </p:spPr>
+        <p:txBody>
+          <a:bodyPr anchorCtr="0" anchor="t" bIns="0" lIns="0" spcFirstLastPara="1" rIns="0" wrap="square" tIns="0">
+            <a:normAutofit/>
+          </a:bodyPr>
+          <a:lstStyle/>
+          <a:p>
+            <a:pPr indent="0" lvl="0" marL="0" marR="0" rtl="0" algn="l">
+              <a:lnSpc>
+                <a:spcPct val="140000"/>
+              </a:lnSpc>
+              <a:spcBef>
+                <a:spcPts val="0"/>
+              </a:spcBef>
+              <a:spcAft>
+                <a:spcPts val="0"/>
+              </a:spcAft>
+              <a:buClr>
+                <a:srgbClr val="8A6A2B"/>
+              </a:buClr>
+              <a:buSzPts val="1200"/>
+              <a:buFont typeface="Times New Roman"/>
+              <a:buNone/>
+            </a:pPr>
+            <a:r>
+              <a:rPr b="1" i="0" lang="en-US" spc="100" sz="1200" u="none" cap="none" strike="noStrike">
+                <a:solidFill>
+                  <a:srgbClr val="8A6A2B"/>
+                </a:solidFill>
+                <a:latin typeface="Times New Roman"/>
+                <a:ea typeface="Times New Roman"/>
+                <a:cs typeface="Times New Roman"/>
+                <a:sym typeface="Times New Roman"/>
+              </a:rPr>
+              <a:t>CONCLUSION AND WHAT WE LEARNED</a:t>
+            </a:r>
+            <a:endParaRPr b="0" i="0" sz="1200" u="none" cap="none" strike="noStrike">
+              <a:solidFill>
+                <a:schemeClr val="dk1"/>
+              </a:solidFill>
+              <a:latin typeface="Times New Roman"/>
+              <a:ea typeface="Times New Roman"/>
+              <a:cs typeface="Times New Roman"/>
+              <a:sym typeface="Times New Roman"/>
+            </a:endParaRPr>
+          </a:p>
+        </p:txBody>
+      </p:sp>
+      <p:sp>
+        <p:nvSpPr>
+          <p:cNvPr id="427" name="Google Shape;427;p15"/>
+          <p:cNvSpPr txBox="1"/>
+          <p:nvPr>
+            <p:ph type="title"/>
+          </p:nvPr>
+        </p:nvSpPr>
+        <p:spPr>
+          <a:xfrm>
+            <a:off x="812800" y="1102320"/>
+            <a:ext cx="10883392" cy="444500"/>
+          </a:xfrm>
+          <a:prstGeom prst="rect">
+            <a:avLst/>
+          </a:prstGeom>
+          <a:noFill/>
+          <a:ln>
+            <a:noFill/>
+          </a:ln>
+        </p:spPr>
+        <p:txBody>
+          <a:bodyPr anchorCtr="0" anchor="t" bIns="0" lIns="0" spcFirstLastPara="1" rIns="0" wrap="square" tIns="0">
+            <a:normAutofit/>
+          </a:bodyPr>
+          <a:lstStyle/>
+          <a:p>
+            <a:pPr indent="0" lvl="0" marL="0" rtl="0" algn="l">
+              <a:lnSpc>
+                <a:spcPct val="110000"/>
+              </a:lnSpc>
+              <a:spcBef>
+                <a:spcPts val="0"/>
+              </a:spcBef>
+              <a:spcAft>
+                <a:spcPts val="0"/>
+              </a:spcAft>
+              <a:buClr>
+                <a:srgbClr val="1C1A17"/>
+              </a:buClr>
+              <a:buSzPts val="3000"/>
+              <a:buFont typeface="Times New Roman"/>
+              <a:buNone/>
+            </a:pPr>
+            <a:r>
+              <a:rPr b="1" i="0" lang="en-US" sz="3000">
+                <a:solidFill>
+                  <a:srgbClr val="1C1A17"/>
+                </a:solidFill>
+                <a:latin typeface="Times New Roman"/>
+                <a:ea typeface="Times New Roman"/>
+                <a:cs typeface="Times New Roman"/>
+                <a:sym typeface="Times New Roman"/>
+              </a:rPr>
+              <a:t>What we built, what we found, what we learned</a:t>
+            </a:r>
+            <a:endParaRPr sz="3000"/>
+          </a:p>
+        </p:txBody>
+      </p:sp>
+      <p:sp>
+        <p:nvSpPr>
+          <p:cNvPr id="454" name="Google Shape;454;p15"/>
+          <p:cNvSpPr/>
+          <p:nvPr/>
+        </p:nvSpPr>
+        <p:spPr>
+          <a:xfrm>
+            <a:off x="812800" y="6238280"/>
+            <a:ext cx="2092404" cy="238720"/>
+          </a:xfrm>
+          <a:prstGeom prst="rect">
+            <a:avLst/>
+          </a:prstGeom>
+          <a:noFill/>
+          <a:ln>
+            <a:noFill/>
+          </a:ln>
+        </p:spPr>
+        <p:txBody>
+          <a:bodyPr anchorCtr="0" anchor="t" bIns="0" lIns="0" spcFirstLastPara="1" rIns="0" wrap="square" tIns="0">
+            <a:normAutofit/>
+          </a:bodyPr>
+          <a:lstStyle/>
+          <a:p>
+            <a:pPr indent="0" lvl="0" marL="0" marR="0" rtl="0" algn="l">
+              <a:lnSpc>
+                <a:spcPct val="140000"/>
+              </a:lnSpc>
+              <a:spcBef>
+                <a:spcPts val="0"/>
+              </a:spcBef>
+              <a:spcAft>
+                <a:spcPts val="0"/>
+              </a:spcAft>
+              <a:buClr>
+                <a:srgbClr val="6E665C"/>
+              </a:buClr>
+              <a:buSzPts val="1200"/>
+              <a:buFont typeface="Times New Roman"/>
+              <a:buNone/>
+            </a:pPr>
+            <a:r>
+              <a:rPr b="0" i="0" lang="en-US" sz="1200" u="none" cap="none" strike="noStrike">
+                <a:solidFill>
+                  <a:srgbClr val="6E665C"/>
+                </a:solidFill>
+                <a:latin typeface="Times New Roman"/>
+                <a:ea typeface="Times New Roman"/>
+                <a:cs typeface="Times New Roman"/>
+                <a:sym typeface="Times New Roman"/>
+              </a:rPr>
+              <a:t>Cornhole Biomechanics Lab</a:t>
+            </a:r>
+            <a:endParaRPr b="0" i="0" sz="1200" u="none" cap="none" strike="noStrike">
+              <a:solidFill>
+                <a:schemeClr val="dk1"/>
+              </a:solidFill>
+              <a:latin typeface="Times New Roman"/>
+              <a:ea typeface="Times New Roman"/>
+              <a:cs typeface="Times New Roman"/>
+              <a:sym typeface="Times New Roman"/>
+            </a:endParaRPr>
+          </a:p>
+        </p:txBody>
+      </p:sp>
+      <p:sp>
+        <p:nvSpPr>
+          <p:cNvPr id="455" name="Google Shape;455;p15"/>
+          <p:cNvSpPr/>
+          <p:nvPr/>
+        </p:nvSpPr>
+        <p:spPr>
+          <a:xfrm>
+            <a:off x="9758878" y="6238280"/>
+            <a:ext cx="1620322" cy="238720"/>
+          </a:xfrm>
+          <a:prstGeom prst="rect">
+            <a:avLst/>
+          </a:prstGeom>
+          <a:noFill/>
+          <a:ln>
+            <a:noFill/>
+          </a:ln>
+        </p:spPr>
+        <p:txBody>
+          <a:bodyPr anchorCtr="0" anchor="t" bIns="0" lIns="0" spcFirstLastPara="1" rIns="0" wrap="square" tIns="0">
+            <a:normAutofit/>
+          </a:bodyPr>
+          <a:lstStyle/>
+          <a:p>
+            <a:pPr indent="0" lvl="0" marL="0" marR="0" rtl="0" algn="r">
+              <a:lnSpc>
+                <a:spcPct val="140000"/>
+              </a:lnSpc>
+              <a:spcBef>
+                <a:spcPts val="0"/>
+              </a:spcBef>
+              <a:spcAft>
+                <a:spcPts val="0"/>
+              </a:spcAft>
+              <a:buClr>
+                <a:srgbClr val="6E665C"/>
+              </a:buClr>
+              <a:buSzPts val="1200"/>
+              <a:buFont typeface="Times New Roman"/>
+              <a:buNone/>
+            </a:pPr>
+            <a:r>
+              <a:rPr b="0" i="0" lang="en-US" sz="1200" u="none" cap="none" strike="noStrike">
+                <a:solidFill>
+                  <a:srgbClr val="6E665C"/>
+                </a:solidFill>
+                <a:latin typeface="Times New Roman"/>
+                <a:ea typeface="Times New Roman"/>
+                <a:cs typeface="Times New Roman"/>
+                <a:sym typeface="Times New Roman"/>
+              </a:rPr>
+              <a:t>Eliam Chang · 12 / 12</a:t>
+            </a:r>
+            <a:endParaRPr b="0" i="0" sz="1200" u="none" cap="none" strike="noStrike">
+              <a:solidFill>
+                <a:schemeClr val="dk1"/>
+              </a:solidFill>
+              <a:latin typeface="Times New Roman"/>
+              <a:ea typeface="Times New Roman"/>
+              <a:cs typeface="Times New Roman"/>
+              <a:sym typeface="Times New Roman"/>
+            </a:endParaRPr>
+          </a:p>
+        </p:txBody>
+      </p:sp>
+      <p:sp>
+        <p:nvSpPr>
+          <p:cNvPr id="456" name="Rounded Rectangle 455"/>
+          <p:cNvSpPr/>
+          <p:nvPr/>
+        </p:nvSpPr>
+        <p:spPr>
+          <a:xfrm>
+            <a:off x="822960" y="1691640"/>
+            <a:ext cx="3383280" cy="2103120"/>
+          </a:xfrm>
+          <a:prstGeom prst="roundRect">
+            <a:avLst>
+              <a:gd name="adj" fmla="val 2000"/>
+            </a:avLst>
+          </a:prstGeom>
+          <a:solidFill>
+            <a:srgbClr val="FFFEFB"/>
+          </a:solidFill>
+          <a:ln w="12700">
+            <a:solidFill>
+              <a:srgbClr val="E3DCCF"/>
+            </a:solidFill>
+          </a:ln>
+          <a:effectLst/>
+        </p:spPr>
+        <p:style>
+          <a:lnRef idx="1">
+            <a:schemeClr val="accent1"/>
+          </a:lnRef>
+          <a:fillRef idx="3">
+            <a:schemeClr val="accent1"/>
+          </a:fillRef>
+          <a:effectRef idx="2">
+            <a:schemeClr val="accent1"/>
+          </a:effectRef>
+          <a:fontRef idx="minor">
+            <a:schemeClr val="lt1"/>
+          </a:fontRef>
+        </p:style>
+        <p:txBody>
+          <a:bodyPr rtlCol="0" anchor="ctr"/>
+          <a:lstStyle/>
+          <a:p/>
+        </p:txBody>
+      </p:sp>
+      <p:sp>
+        <p:nvSpPr>
+          <p:cNvPr id="457" name="TextBox 456"/>
+          <p:cNvSpPr txBox="1"/>
+          <p:nvPr/>
+        </p:nvSpPr>
+        <p:spPr>
+          <a:xfrm>
+            <a:off x="1005840" y="1801368"/>
+            <a:ext cx="3017520" cy="219456"/>
+          </a:xfrm>
+          <a:prstGeom prst="rect">
+            <a:avLst/>
+          </a:prstGeom>
+          <a:noFill/>
+        </p:spPr>
+        <p:txBody>
+          <a:bodyPr wrap="square" lIns="0" rIns="0" tIns="0" bIns="0" anchor="t">
+            <a:spAutoFit/>
+          </a:bodyPr>
+          <a:lstStyle/>
+          <a:p>
+            <a:pPr algn="l">
+              <a:lnSpc>
+                <a:spcPct val="130000"/>
+              </a:lnSpc>
+            </a:pPr>
+            <a:r>
+              <a:rPr sz="1100" b="1" i="0">
+                <a:solidFill>
+                  <a:srgbClr val="2F5D8A"/>
+                </a:solidFill>
+                <a:latin typeface="Times New Roman"/>
+              </a:rPr>
+              <a:t>WE BUILT</a:t>
+            </a:r>
+          </a:p>
+        </p:txBody>
+      </p:sp>
+      <p:sp>
+        <p:nvSpPr>
+          <p:cNvPr id="458" name="TextBox 457"/>
+          <p:cNvSpPr txBox="1"/>
+          <p:nvPr/>
+        </p:nvSpPr>
+        <p:spPr>
+          <a:xfrm>
+            <a:off x="1005840" y="2011680"/>
+            <a:ext cx="3017520" cy="502920"/>
+          </a:xfrm>
+          <a:prstGeom prst="rect">
+            <a:avLst/>
+          </a:prstGeom>
+          <a:noFill/>
+        </p:spPr>
+        <p:txBody>
+          <a:bodyPr wrap="square" lIns="0" rIns="0" tIns="0" bIns="0" anchor="t">
+            <a:spAutoFit/>
+          </a:bodyPr>
+          <a:lstStyle/>
+          <a:p>
+            <a:pPr algn="l">
+              <a:lnSpc>
+                <a:spcPct val="100000"/>
+              </a:lnSpc>
+            </a:pPr>
+            <a:r>
+              <a:rPr sz="2800" b="1" i="0">
+                <a:solidFill>
+                  <a:srgbClr val="2F5D8A"/>
+                </a:solidFill>
+                <a:latin typeface="Times New Roman"/>
+              </a:rPr>
+              <a:t>2 phones</a:t>
+            </a:r>
+          </a:p>
+        </p:txBody>
+      </p:sp>
+      <p:sp>
+        <p:nvSpPr>
+          <p:cNvPr id="459" name="TextBox 458"/>
+          <p:cNvSpPr txBox="1"/>
+          <p:nvPr/>
+        </p:nvSpPr>
+        <p:spPr>
+          <a:xfrm>
+            <a:off x="1005840" y="2542032"/>
+            <a:ext cx="3017520" cy="237744"/>
+          </a:xfrm>
+          <a:prstGeom prst="rect">
+            <a:avLst/>
+          </a:prstGeom>
+          <a:noFill/>
+        </p:spPr>
+        <p:txBody>
+          <a:bodyPr wrap="square" lIns="0" rIns="0" tIns="0" bIns="0" anchor="t">
+            <a:spAutoFit/>
+          </a:bodyPr>
+          <a:lstStyle/>
+          <a:p>
+            <a:pPr algn="l">
+              <a:lnSpc>
+                <a:spcPct val="130000"/>
+              </a:lnSpc>
+            </a:pPr>
+            <a:r>
+              <a:rPr sz="1100" b="0" i="1">
+                <a:solidFill>
+                  <a:srgbClr val="1C1A17"/>
+                </a:solidFill>
+                <a:latin typeface="Times New Roman"/>
+              </a:rPr>
+              <a:t>and a Mac, no sensors</a:t>
+            </a:r>
+          </a:p>
+        </p:txBody>
+      </p:sp>
+      <p:sp>
+        <p:nvSpPr>
+          <p:cNvPr id="460" name="TextBox 459"/>
+          <p:cNvSpPr txBox="1"/>
+          <p:nvPr/>
+        </p:nvSpPr>
+        <p:spPr>
+          <a:xfrm>
+            <a:off x="1005840" y="2834640"/>
+            <a:ext cx="3017520" cy="914400"/>
+          </a:xfrm>
+          <a:prstGeom prst="rect">
+            <a:avLst/>
+          </a:prstGeom>
+          <a:noFill/>
+        </p:spPr>
+        <p:txBody>
+          <a:bodyPr wrap="square" lIns="0" rIns="0" tIns="0" bIns="0" anchor="t">
+            <a:spAutoFit/>
+          </a:bodyPr>
+          <a:lstStyle/>
+          <a:p>
+            <a:pPr algn="l">
+              <a:lnSpc>
+                <a:spcPct val="115000"/>
+              </a:lnSpc>
+            </a:pPr>
+            <a:r>
+              <a:rPr sz="1100" b="0" i="0">
+                <a:solidFill>
+                  <a:srgbClr val="57514A"/>
+                </a:solidFill>
+                <a:latin typeface="Times New Roman"/>
+              </a:rPr>
+              <a:t>Body → release → landing → score, synced by sound, checked against gravity, one sentence per throw.</a:t>
+            </a:r>
+          </a:p>
+        </p:txBody>
+      </p:sp>
+      <p:sp>
+        <p:nvSpPr>
+          <p:cNvPr id="461" name="Rounded Rectangle 460"/>
+          <p:cNvSpPr/>
+          <p:nvPr/>
+        </p:nvSpPr>
+        <p:spPr>
+          <a:xfrm>
+            <a:off x="4407408" y="1691640"/>
+            <a:ext cx="3383280" cy="2103120"/>
+          </a:xfrm>
+          <a:prstGeom prst="roundRect">
+            <a:avLst>
+              <a:gd name="adj" fmla="val 2000"/>
+            </a:avLst>
+          </a:prstGeom>
+          <a:solidFill>
+            <a:srgbClr val="FFFEFB"/>
+          </a:solidFill>
+          <a:ln w="12700">
+            <a:solidFill>
+              <a:srgbClr val="E3DCCF"/>
+            </a:solidFill>
+          </a:ln>
+          <a:effectLst/>
+        </p:spPr>
+        <p:style>
+          <a:lnRef idx="1">
+            <a:schemeClr val="accent1"/>
+          </a:lnRef>
+          <a:fillRef idx="3">
+            <a:schemeClr val="accent1"/>
+          </a:fillRef>
+          <a:effectRef idx="2">
+            <a:schemeClr val="accent1"/>
+          </a:effectRef>
+          <a:fontRef idx="minor">
+            <a:schemeClr val="lt1"/>
+          </a:fontRef>
+        </p:style>
+        <p:txBody>
+          <a:bodyPr rtlCol="0" anchor="ctr"/>
+          <a:lstStyle/>
+          <a:p/>
+        </p:txBody>
+      </p:sp>
+      <p:sp>
+        <p:nvSpPr>
+          <p:cNvPr id="462" name="TextBox 461"/>
+          <p:cNvSpPr txBox="1"/>
+          <p:nvPr/>
+        </p:nvSpPr>
+        <p:spPr>
+          <a:xfrm>
+            <a:off x="4590288" y="1801368"/>
+            <a:ext cx="3017520" cy="219456"/>
+          </a:xfrm>
+          <a:prstGeom prst="rect">
+            <a:avLst/>
+          </a:prstGeom>
+          <a:noFill/>
+        </p:spPr>
+        <p:txBody>
+          <a:bodyPr wrap="square" lIns="0" rIns="0" tIns="0" bIns="0" anchor="t">
+            <a:spAutoFit/>
+          </a:bodyPr>
+          <a:lstStyle/>
+          <a:p>
+            <a:pPr algn="l">
+              <a:lnSpc>
+                <a:spcPct val="130000"/>
+              </a:lnSpc>
+            </a:pPr>
+            <a:r>
+              <a:rPr sz="1100" b="1" i="0">
+                <a:solidFill>
+                  <a:srgbClr val="8A6A2B"/>
+                </a:solidFill>
+                <a:latin typeface="Times New Roman"/>
+              </a:rPr>
+              <a:t>WE FOUND</a:t>
+            </a:r>
+          </a:p>
+        </p:txBody>
+      </p:sp>
+      <p:sp>
+        <p:nvSpPr>
+          <p:cNvPr id="463" name="TextBox 462"/>
+          <p:cNvSpPr txBox="1"/>
+          <p:nvPr/>
+        </p:nvSpPr>
+        <p:spPr>
+          <a:xfrm>
+            <a:off x="4590288" y="2011680"/>
+            <a:ext cx="3017520" cy="502920"/>
+          </a:xfrm>
+          <a:prstGeom prst="rect">
+            <a:avLst/>
+          </a:prstGeom>
+          <a:noFill/>
+        </p:spPr>
+        <p:txBody>
+          <a:bodyPr wrap="square" lIns="0" rIns="0" tIns="0" bIns="0" anchor="t">
+            <a:spAutoFit/>
+          </a:bodyPr>
+          <a:lstStyle/>
+          <a:p>
+            <a:pPr algn="l">
+              <a:lnSpc>
+                <a:spcPct val="100000"/>
+              </a:lnSpc>
+            </a:pPr>
+            <a:r>
+              <a:rPr sz="2800" b="1" i="0">
+                <a:solidFill>
+                  <a:srgbClr val="8A6A2B"/>
+                </a:solidFill>
+                <a:latin typeface="Times New Roman"/>
+              </a:rPr>
+              <a:t>13 cm</a:t>
+            </a:r>
+          </a:p>
+        </p:txBody>
+      </p:sp>
+      <p:sp>
+        <p:nvSpPr>
+          <p:cNvPr id="464" name="TextBox 463"/>
+          <p:cNvSpPr txBox="1"/>
+          <p:nvPr/>
+        </p:nvSpPr>
+        <p:spPr>
+          <a:xfrm>
+            <a:off x="4590288" y="2542032"/>
+            <a:ext cx="3017520" cy="237744"/>
+          </a:xfrm>
+          <a:prstGeom prst="rect">
+            <a:avLst/>
+          </a:prstGeom>
+          <a:noFill/>
+        </p:spPr>
+        <p:txBody>
+          <a:bodyPr wrap="square" lIns="0" rIns="0" tIns="0" bIns="0" anchor="t">
+            <a:spAutoFit/>
+          </a:bodyPr>
+          <a:lstStyle/>
+          <a:p>
+            <a:pPr algn="l">
+              <a:lnSpc>
+                <a:spcPct val="130000"/>
+              </a:lnSpc>
+            </a:pPr>
+            <a:r>
+              <a:rPr sz="1100" b="0" i="1">
+                <a:solidFill>
+                  <a:srgbClr val="1C1A17"/>
+                </a:solidFill>
+                <a:latin typeface="Times New Roman"/>
+              </a:rPr>
+              <a:t>per 0.1 m/s of release speed</a:t>
+            </a:r>
+          </a:p>
+        </p:txBody>
+      </p:sp>
+      <p:sp>
+        <p:nvSpPr>
+          <p:cNvPr id="465" name="TextBox 464"/>
+          <p:cNvSpPr txBox="1"/>
+          <p:nvPr/>
+        </p:nvSpPr>
+        <p:spPr>
+          <a:xfrm>
+            <a:off x="4590288" y="2834640"/>
+            <a:ext cx="3017520" cy="914400"/>
+          </a:xfrm>
+          <a:prstGeom prst="rect">
+            <a:avLst/>
+          </a:prstGeom>
+          <a:noFill/>
+        </p:spPr>
+        <p:txBody>
+          <a:bodyPr wrap="square" lIns="0" rIns="0" tIns="0" bIns="0" anchor="t">
+            <a:spAutoFit/>
+          </a:bodyPr>
+          <a:lstStyle/>
+          <a:p>
+            <a:pPr algn="l">
+              <a:lnSpc>
+                <a:spcPct val="115000"/>
+              </a:lnSpc>
+            </a:pPr>
+            <a:r>
+              <a:rPr sz="1100" b="0" i="0">
+                <a:solidFill>
+                  <a:srgbClr val="57514A"/>
+                </a:solidFill>
+                <a:latin typeface="Times New Roman"/>
+              </a:rPr>
+              <a:t>Speed consistency, not angle or power, drives short and long; the slide matters almost as much as the flight.</a:t>
+            </a:r>
+          </a:p>
+        </p:txBody>
+      </p:sp>
+      <p:sp>
+        <p:nvSpPr>
+          <p:cNvPr id="466" name="Rounded Rectangle 465"/>
+          <p:cNvSpPr/>
+          <p:nvPr/>
+        </p:nvSpPr>
+        <p:spPr>
+          <a:xfrm>
+            <a:off x="7991856" y="1691640"/>
+            <a:ext cx="3383280" cy="2103120"/>
+          </a:xfrm>
+          <a:prstGeom prst="roundRect">
+            <a:avLst>
+              <a:gd name="adj" fmla="val 2000"/>
+            </a:avLst>
+          </a:prstGeom>
+          <a:solidFill>
+            <a:srgbClr val="FFFEFB"/>
+          </a:solidFill>
+          <a:ln w="12700">
+            <a:solidFill>
+              <a:srgbClr val="E3DCCF"/>
+            </a:solidFill>
+          </a:ln>
+          <a:effectLst/>
+        </p:spPr>
+        <p:style>
+          <a:lnRef idx="1">
+            <a:schemeClr val="accent1"/>
+          </a:lnRef>
+          <a:fillRef idx="3">
+            <a:schemeClr val="accent1"/>
+          </a:fillRef>
+          <a:effectRef idx="2">
+            <a:schemeClr val="accent1"/>
+          </a:effectRef>
+          <a:fontRef idx="minor">
+            <a:schemeClr val="lt1"/>
+          </a:fontRef>
+        </p:style>
+        <p:txBody>
+          <a:bodyPr rtlCol="0" anchor="ctr"/>
+          <a:lstStyle/>
+          <a:p/>
+        </p:txBody>
+      </p:sp>
+      <p:sp>
+        <p:nvSpPr>
+          <p:cNvPr id="467" name="TextBox 466"/>
+          <p:cNvSpPr txBox="1"/>
+          <p:nvPr/>
+        </p:nvSpPr>
+        <p:spPr>
+          <a:xfrm>
+            <a:off x="8174736" y="1801368"/>
+            <a:ext cx="3017520" cy="219456"/>
+          </a:xfrm>
+          <a:prstGeom prst="rect">
+            <a:avLst/>
+          </a:prstGeom>
+          <a:noFill/>
+        </p:spPr>
+        <p:txBody>
+          <a:bodyPr wrap="square" lIns="0" rIns="0" tIns="0" bIns="0" anchor="t">
+            <a:spAutoFit/>
+          </a:bodyPr>
+          <a:lstStyle/>
+          <a:p>
+            <a:pPr algn="l">
+              <a:lnSpc>
+                <a:spcPct val="130000"/>
+              </a:lnSpc>
+            </a:pPr>
+            <a:r>
+              <a:rPr sz="1100" b="1" i="0">
+                <a:solidFill>
+                  <a:srgbClr val="A8432A"/>
+                </a:solidFill>
+                <a:latin typeface="Times New Roman"/>
+              </a:rPr>
+              <a:t>WHAT COMES NEXT</a:t>
+            </a:r>
+          </a:p>
+        </p:txBody>
+      </p:sp>
+      <p:sp>
+        <p:nvSpPr>
+          <p:cNvPr id="468" name="TextBox 467"/>
+          <p:cNvSpPr txBox="1"/>
+          <p:nvPr/>
+        </p:nvSpPr>
+        <p:spPr>
+          <a:xfrm>
+            <a:off x="8174736" y="2011680"/>
+            <a:ext cx="3017520" cy="502920"/>
+          </a:xfrm>
+          <a:prstGeom prst="rect">
+            <a:avLst/>
+          </a:prstGeom>
+          <a:noFill/>
+        </p:spPr>
+        <p:txBody>
+          <a:bodyPr wrap="square" lIns="0" rIns="0" tIns="0" bIns="0" anchor="t">
+            <a:spAutoFit/>
+          </a:bodyPr>
+          <a:lstStyle/>
+          <a:p>
+            <a:pPr algn="l">
+              <a:lnSpc>
+                <a:spcPct val="100000"/>
+              </a:lnSpc>
+            </a:pPr>
+            <a:r>
+              <a:rPr sz="2800" b="1" i="0">
+                <a:solidFill>
+                  <a:srgbClr val="A8432A"/>
+                </a:solidFill>
+                <a:latin typeface="Times New Roman"/>
+              </a:rPr>
+              <a:t>4–6 weeks</a:t>
+            </a:r>
+          </a:p>
+        </p:txBody>
+      </p:sp>
+      <p:sp>
+        <p:nvSpPr>
+          <p:cNvPr id="469" name="TextBox 468"/>
+          <p:cNvSpPr txBox="1"/>
+          <p:nvPr/>
+        </p:nvSpPr>
+        <p:spPr>
+          <a:xfrm>
+            <a:off x="8174736" y="2542032"/>
+            <a:ext cx="3017520" cy="237744"/>
+          </a:xfrm>
+          <a:prstGeom prst="rect">
+            <a:avLst/>
+          </a:prstGeom>
+          <a:noFill/>
+        </p:spPr>
+        <p:txBody>
+          <a:bodyPr wrap="square" lIns="0" rIns="0" tIns="0" bIns="0" anchor="t">
+            <a:spAutoFit/>
+          </a:bodyPr>
+          <a:lstStyle/>
+          <a:p>
+            <a:pPr algn="l">
+              <a:lnSpc>
+                <a:spcPct val="130000"/>
+              </a:lnSpc>
+            </a:pPr>
+            <a:r>
+              <a:rPr sz="1100" b="0" i="1">
+                <a:solidFill>
+                  <a:srgbClr val="1C1A17"/>
+                </a:solidFill>
+                <a:latin typeface="Times New Roman"/>
+              </a:rPr>
+              <a:t>to prove it raises PPR</a:t>
+            </a:r>
+          </a:p>
+        </p:txBody>
+      </p:sp>
+      <p:sp>
+        <p:nvSpPr>
+          <p:cNvPr id="470" name="TextBox 469"/>
+          <p:cNvSpPr txBox="1"/>
+          <p:nvPr/>
+        </p:nvSpPr>
+        <p:spPr>
+          <a:xfrm>
+            <a:off x="8174736" y="2834640"/>
+            <a:ext cx="3017520" cy="914400"/>
+          </a:xfrm>
+          <a:prstGeom prst="rect">
+            <a:avLst/>
+          </a:prstGeom>
+          <a:noFill/>
+        </p:spPr>
+        <p:txBody>
+          <a:bodyPr wrap="square" lIns="0" rIns="0" tIns="0" bIns="0" anchor="t">
+            <a:spAutoFit/>
+          </a:bodyPr>
+          <a:lstStyle/>
+          <a:p>
+            <a:pPr algn="l">
+              <a:lnSpc>
+                <a:spcPct val="115000"/>
+              </a:lnSpc>
+            </a:pPr>
+            <a:r>
+              <a:rPr sz="1100" b="0" i="0">
+                <a:solidFill>
+                  <a:srgbClr val="57514A"/>
+                </a:solidFill>
+                <a:latin typeface="Times New Roman"/>
+              </a:rPr>
+              <a:t>Alternate weeks with and without feedback, 40 throws per athlete per week, plus a blinded validation check.</a:t>
+            </a:r>
+          </a:p>
+        </p:txBody>
+      </p:sp>
+      <p:sp>
+        <p:nvSpPr>
+          <p:cNvPr id="471" name="Rounded Rectangle 470"/>
+          <p:cNvSpPr/>
+          <p:nvPr/>
+        </p:nvSpPr>
+        <p:spPr>
+          <a:xfrm>
+            <a:off x="822960" y="3931920"/>
+            <a:ext cx="2528316" cy="1188720"/>
+          </a:xfrm>
+          <a:prstGeom prst="roundRect">
+            <a:avLst>
+              <a:gd name="adj" fmla="val 2000"/>
+            </a:avLst>
+          </a:prstGeom>
+          <a:solidFill>
+            <a:srgbClr val="FFFEFB"/>
+          </a:solidFill>
+          <a:ln w="12700">
+            <a:solidFill>
+              <a:srgbClr val="E3DCCF"/>
+            </a:solidFill>
+          </a:ln>
+          <a:effectLst/>
+        </p:spPr>
+        <p:style>
+          <a:lnRef idx="1">
+            <a:schemeClr val="accent1"/>
+          </a:lnRef>
+          <a:fillRef idx="3">
+            <a:schemeClr val="accent1"/>
+          </a:fillRef>
+          <a:effectRef idx="2">
+            <a:schemeClr val="accent1"/>
+          </a:effectRef>
+          <a:fontRef idx="minor">
+            <a:schemeClr val="lt1"/>
+          </a:fontRef>
+        </p:style>
+        <p:txBody>
+          <a:bodyPr rtlCol="0" anchor="ctr"/>
+          <a:lstStyle/>
+          <a:p/>
+        </p:txBody>
+      </p:sp>
+      <p:sp>
+        <p:nvSpPr>
+          <p:cNvPr id="472" name="TextBox 471"/>
+          <p:cNvSpPr txBox="1"/>
+          <p:nvPr/>
+        </p:nvSpPr>
+        <p:spPr>
+          <a:xfrm>
+            <a:off x="960120" y="4023360"/>
+            <a:ext cx="2258568" cy="219456"/>
+          </a:xfrm>
+          <a:prstGeom prst="rect">
+            <a:avLst/>
+          </a:prstGeom>
+          <a:noFill/>
+        </p:spPr>
+        <p:txBody>
+          <a:bodyPr wrap="square" lIns="0" rIns="0" tIns="0" bIns="0" anchor="t">
+            <a:spAutoFit/>
+          </a:bodyPr>
+          <a:lstStyle/>
+          <a:p>
+            <a:pPr algn="l">
+              <a:lnSpc>
+                <a:spcPct val="130000"/>
+              </a:lnSpc>
+            </a:pPr>
+            <a:r>
+              <a:rPr sz="1200" b="1" i="0">
+                <a:solidFill>
+                  <a:srgbClr val="1C1A17"/>
+                </a:solidFill>
+                <a:latin typeface="Times New Roman"/>
+              </a:rPr>
+              <a:t>Hardest part</a:t>
+            </a:r>
+          </a:p>
+        </p:txBody>
+      </p:sp>
+      <p:sp>
+        <p:nvSpPr>
+          <p:cNvPr id="473" name="TextBox 472"/>
+          <p:cNvSpPr txBox="1"/>
+          <p:nvPr/>
+        </p:nvSpPr>
+        <p:spPr>
+          <a:xfrm>
+            <a:off x="960120" y="4279392"/>
+            <a:ext cx="2258568" cy="777240"/>
+          </a:xfrm>
+          <a:prstGeom prst="rect">
+            <a:avLst/>
+          </a:prstGeom>
+          <a:noFill/>
+        </p:spPr>
+        <p:txBody>
+          <a:bodyPr wrap="square" lIns="0" rIns="0" tIns="0" bIns="0" anchor="t">
+            <a:spAutoFit/>
+          </a:bodyPr>
+          <a:lstStyle/>
+          <a:p>
+            <a:pPr algn="l">
+              <a:lnSpc>
+                <a:spcPct val="110000"/>
+              </a:lnSpc>
+            </a:pPr>
+            <a:r>
+              <a:rPr sz="1050" b="0" i="0">
+                <a:solidFill>
+                  <a:srgbClr val="57514A"/>
+                </a:solidFill>
+                <a:latin typeface="Times New Roman"/>
+              </a:rPr>
+              <a:t>A red bag on a red board in a busy gym: one tracking error spreads into every metre.</a:t>
+            </a:r>
+          </a:p>
+        </p:txBody>
+      </p:sp>
+      <p:sp>
+        <p:nvSpPr>
+          <p:cNvPr id="474" name="Rounded Rectangle 473"/>
+          <p:cNvSpPr/>
+          <p:nvPr/>
+        </p:nvSpPr>
+        <p:spPr>
+          <a:xfrm>
+            <a:off x="3497579" y="3931920"/>
+            <a:ext cx="2528316" cy="1188720"/>
+          </a:xfrm>
+          <a:prstGeom prst="roundRect">
+            <a:avLst>
+              <a:gd name="adj" fmla="val 2000"/>
+            </a:avLst>
+          </a:prstGeom>
+          <a:solidFill>
+            <a:srgbClr val="FFFEFB"/>
+          </a:solidFill>
+          <a:ln w="12700">
+            <a:solidFill>
+              <a:srgbClr val="E3DCCF"/>
+            </a:solidFill>
+          </a:ln>
+          <a:effectLst/>
+        </p:spPr>
+        <p:style>
+          <a:lnRef idx="1">
+            <a:schemeClr val="accent1"/>
+          </a:lnRef>
+          <a:fillRef idx="3">
+            <a:schemeClr val="accent1"/>
+          </a:fillRef>
+          <a:effectRef idx="2">
+            <a:schemeClr val="accent1"/>
+          </a:effectRef>
+          <a:fontRef idx="minor">
+            <a:schemeClr val="lt1"/>
+          </a:fontRef>
+        </p:style>
+        <p:txBody>
+          <a:bodyPr rtlCol="0" anchor="ctr"/>
+          <a:lstStyle/>
+          <a:p/>
+        </p:txBody>
+      </p:sp>
+      <p:sp>
+        <p:nvSpPr>
+          <p:cNvPr id="475" name="TextBox 474"/>
+          <p:cNvSpPr txBox="1"/>
+          <p:nvPr/>
+        </p:nvSpPr>
+        <p:spPr>
+          <a:xfrm>
+            <a:off x="3634739" y="4023360"/>
+            <a:ext cx="2258568" cy="219456"/>
+          </a:xfrm>
+          <a:prstGeom prst="rect">
+            <a:avLst/>
+          </a:prstGeom>
+          <a:noFill/>
+        </p:spPr>
+        <p:txBody>
+          <a:bodyPr wrap="square" lIns="0" rIns="0" tIns="0" bIns="0" anchor="t">
+            <a:spAutoFit/>
+          </a:bodyPr>
+          <a:lstStyle/>
+          <a:p>
+            <a:pPr algn="l">
+              <a:lnSpc>
+                <a:spcPct val="130000"/>
+              </a:lnSpc>
+            </a:pPr>
+            <a:r>
+              <a:rPr sz="1200" b="1" i="0">
+                <a:solidFill>
+                  <a:srgbClr val="1C1A17"/>
+                </a:solidFill>
+                <a:latin typeface="Times New Roman"/>
+              </a:rPr>
+              <a:t>What surprised us</a:t>
+            </a:r>
+          </a:p>
+        </p:txBody>
+      </p:sp>
+      <p:sp>
+        <p:nvSpPr>
+          <p:cNvPr id="476" name="TextBox 475"/>
+          <p:cNvSpPr txBox="1"/>
+          <p:nvPr/>
+        </p:nvSpPr>
+        <p:spPr>
+          <a:xfrm>
+            <a:off x="3634739" y="4279392"/>
+            <a:ext cx="2258568" cy="777240"/>
+          </a:xfrm>
+          <a:prstGeom prst="rect">
+            <a:avLst/>
+          </a:prstGeom>
+          <a:noFill/>
+        </p:spPr>
+        <p:txBody>
+          <a:bodyPr wrap="square" lIns="0" rIns="0" tIns="0" bIns="0" anchor="t">
+            <a:spAutoFit/>
+          </a:bodyPr>
+          <a:lstStyle/>
+          <a:p>
+            <a:pPr algn="l">
+              <a:lnSpc>
+                <a:spcPct val="110000"/>
+              </a:lnSpc>
+            </a:pPr>
+            <a:r>
+              <a:rPr sz="1050" b="0" i="0">
+                <a:solidFill>
+                  <a:srgbClr val="57514A"/>
+                </a:solidFill>
+                <a:latin typeface="Times New Roman"/>
+              </a:rPr>
+              <a:t>All four release at the same speed; they differ in consistency. 4K tracked worse than 1080p.</a:t>
+            </a:r>
+          </a:p>
+        </p:txBody>
+      </p:sp>
+      <p:sp>
+        <p:nvSpPr>
+          <p:cNvPr id="477" name="Rounded Rectangle 476"/>
+          <p:cNvSpPr/>
+          <p:nvPr/>
+        </p:nvSpPr>
+        <p:spPr>
+          <a:xfrm>
+            <a:off x="6172200" y="3931920"/>
+            <a:ext cx="2528316" cy="1188720"/>
+          </a:xfrm>
+          <a:prstGeom prst="roundRect">
+            <a:avLst>
+              <a:gd name="adj" fmla="val 2000"/>
+            </a:avLst>
+          </a:prstGeom>
+          <a:solidFill>
+            <a:srgbClr val="FFFEFB"/>
+          </a:solidFill>
+          <a:ln w="12700">
+            <a:solidFill>
+              <a:srgbClr val="E3DCCF"/>
+            </a:solidFill>
+          </a:ln>
+          <a:effectLst/>
+        </p:spPr>
+        <p:style>
+          <a:lnRef idx="1">
+            <a:schemeClr val="accent1"/>
+          </a:lnRef>
+          <a:fillRef idx="3">
+            <a:schemeClr val="accent1"/>
+          </a:fillRef>
+          <a:effectRef idx="2">
+            <a:schemeClr val="accent1"/>
+          </a:effectRef>
+          <a:fontRef idx="minor">
+            <a:schemeClr val="lt1"/>
+          </a:fontRef>
+        </p:style>
+        <p:txBody>
+          <a:bodyPr rtlCol="0" anchor="ctr"/>
+          <a:lstStyle/>
+          <a:p/>
+        </p:txBody>
+      </p:sp>
+      <p:sp>
+        <p:nvSpPr>
+          <p:cNvPr id="478" name="TextBox 477"/>
+          <p:cNvSpPr txBox="1"/>
+          <p:nvPr/>
+        </p:nvSpPr>
+        <p:spPr>
+          <a:xfrm>
+            <a:off x="6309360" y="4023360"/>
+            <a:ext cx="2258568" cy="219456"/>
+          </a:xfrm>
+          <a:prstGeom prst="rect">
+            <a:avLst/>
+          </a:prstGeom>
+          <a:noFill/>
+        </p:spPr>
+        <p:txBody>
+          <a:bodyPr wrap="square" lIns="0" rIns="0" tIns="0" bIns="0" anchor="t">
+            <a:spAutoFit/>
+          </a:bodyPr>
+          <a:lstStyle/>
+          <a:p>
+            <a:pPr algn="l">
+              <a:lnSpc>
+                <a:spcPct val="130000"/>
+              </a:lnSpc>
+            </a:pPr>
+            <a:r>
+              <a:rPr sz="1200" b="1" i="0">
+                <a:solidFill>
+                  <a:srgbClr val="1C1A17"/>
+                </a:solidFill>
+                <a:latin typeface="Times New Roman"/>
+              </a:rPr>
+              <a:t>Do differently</a:t>
+            </a:r>
+          </a:p>
+        </p:txBody>
+      </p:sp>
+      <p:sp>
+        <p:nvSpPr>
+          <p:cNvPr id="479" name="TextBox 478"/>
+          <p:cNvSpPr txBox="1"/>
+          <p:nvPr/>
+        </p:nvSpPr>
+        <p:spPr>
+          <a:xfrm>
+            <a:off x="6309360" y="4279392"/>
+            <a:ext cx="2258568" cy="777240"/>
+          </a:xfrm>
+          <a:prstGeom prst="rect">
+            <a:avLst/>
+          </a:prstGeom>
+          <a:noFill/>
+        </p:spPr>
+        <p:txBody>
+          <a:bodyPr wrap="square" lIns="0" rIns="0" tIns="0" bIns="0" anchor="t">
+            <a:spAutoFit/>
+          </a:bodyPr>
+          <a:lstStyle/>
+          <a:p>
+            <a:pPr algn="l">
+              <a:lnSpc>
+                <a:spcPct val="110000"/>
+              </a:lnSpc>
+            </a:pPr>
+            <a:r>
+              <a:rPr sz="1050" b="0" i="0">
+                <a:solidFill>
+                  <a:srgbClr val="57514A"/>
+                </a:solidFill>
+                <a:latin typeface="Times New Roman"/>
+              </a:rPr>
+              <a:t>Contrasting bag, 120 fps side camera, regulation distance, 40+ throws, a left-hander.</a:t>
+            </a:r>
+          </a:p>
+        </p:txBody>
+      </p:sp>
+      <p:sp>
+        <p:nvSpPr>
+          <p:cNvPr id="480" name="Rounded Rectangle 479"/>
+          <p:cNvSpPr/>
+          <p:nvPr/>
+        </p:nvSpPr>
+        <p:spPr>
+          <a:xfrm>
+            <a:off x="8846819" y="3931920"/>
+            <a:ext cx="2528316" cy="1188720"/>
+          </a:xfrm>
+          <a:prstGeom prst="roundRect">
+            <a:avLst>
+              <a:gd name="adj" fmla="val 2000"/>
+            </a:avLst>
+          </a:prstGeom>
+          <a:solidFill>
+            <a:srgbClr val="FFFEFB"/>
+          </a:solidFill>
+          <a:ln w="12700">
+            <a:solidFill>
+              <a:srgbClr val="E3DCCF"/>
+            </a:solidFill>
+          </a:ln>
+          <a:effectLst/>
+        </p:spPr>
+        <p:style>
+          <a:lnRef idx="1">
+            <a:schemeClr val="accent1"/>
+          </a:lnRef>
+          <a:fillRef idx="3">
+            <a:schemeClr val="accent1"/>
+          </a:fillRef>
+          <a:effectRef idx="2">
+            <a:schemeClr val="accent1"/>
+          </a:effectRef>
+          <a:fontRef idx="minor">
+            <a:schemeClr val="lt1"/>
+          </a:fontRef>
+        </p:style>
+        <p:txBody>
+          <a:bodyPr rtlCol="0" anchor="ctr"/>
+          <a:lstStyle/>
+          <a:p/>
+        </p:txBody>
+      </p:sp>
+      <p:sp>
+        <p:nvSpPr>
+          <p:cNvPr id="481" name="TextBox 480"/>
+          <p:cNvSpPr txBox="1"/>
+          <p:nvPr/>
+        </p:nvSpPr>
+        <p:spPr>
+          <a:xfrm>
+            <a:off x="8983980" y="4023360"/>
+            <a:ext cx="2258568" cy="219456"/>
+          </a:xfrm>
+          <a:prstGeom prst="rect">
+            <a:avLst/>
+          </a:prstGeom>
+          <a:noFill/>
+        </p:spPr>
+        <p:txBody>
+          <a:bodyPr wrap="square" lIns="0" rIns="0" tIns="0" bIns="0" anchor="t">
+            <a:spAutoFit/>
+          </a:bodyPr>
+          <a:lstStyle/>
+          <a:p>
+            <a:pPr algn="l">
+              <a:lnSpc>
+                <a:spcPct val="130000"/>
+              </a:lnSpc>
+            </a:pPr>
+            <a:r>
+              <a:rPr sz="1200" b="1" i="0">
+                <a:solidFill>
+                  <a:srgbClr val="1C1A17"/>
+                </a:solidFill>
+                <a:latin typeface="Times New Roman"/>
+              </a:rPr>
+              <a:t>Kept us up at night</a:t>
+            </a:r>
+          </a:p>
+        </p:txBody>
+      </p:sp>
+      <p:sp>
+        <p:nvSpPr>
+          <p:cNvPr id="482" name="TextBox 481"/>
+          <p:cNvSpPr txBox="1"/>
+          <p:nvPr/>
+        </p:nvSpPr>
+        <p:spPr>
+          <a:xfrm>
+            <a:off x="8983980" y="4279392"/>
+            <a:ext cx="2258568" cy="777240"/>
+          </a:xfrm>
+          <a:prstGeom prst="rect">
+            <a:avLst/>
+          </a:prstGeom>
+          <a:noFill/>
+        </p:spPr>
+        <p:txBody>
+          <a:bodyPr wrap="square" lIns="0" rIns="0" tIns="0" bIns="0" anchor="t">
+            <a:spAutoFit/>
+          </a:bodyPr>
+          <a:lstStyle/>
+          <a:p>
+            <a:pPr algn="l">
+              <a:lnSpc>
+                <a:spcPct val="110000"/>
+              </a:lnSpc>
+            </a:pPr>
+            <a:r>
+              <a:rPr sz="1050" b="0" i="0">
+                <a:solidFill>
+                  <a:srgbClr val="57514A"/>
+                </a:solidFill>
+                <a:latin typeface="Times New Roman"/>
+              </a:rPr>
+              <a:t>Advice from noise, and no gold standard yet. Hence the evidence gate.</a:t>
+            </a:r>
+          </a:p>
+        </p:txBody>
+      </p:sp>
+      <p:sp>
+        <p:nvSpPr>
+          <p:cNvPr id="483" name="Rounded Rectangle 482"/>
+          <p:cNvSpPr/>
+          <p:nvPr/>
+        </p:nvSpPr>
+        <p:spPr>
+          <a:xfrm>
+            <a:off x="822960" y="5257800"/>
+            <a:ext cx="10552176" cy="777240"/>
+          </a:xfrm>
+          <a:prstGeom prst="roundRect">
+            <a:avLst>
+              <a:gd name="adj" fmla="val 2000"/>
+            </a:avLst>
+          </a:prstGeom>
+          <a:solidFill>
+            <a:srgbClr val="1C1A17"/>
+          </a:solidFill>
+          <a:ln>
+            <a:noFill/>
+          </a:ln>
+          <a:effectLst/>
+        </p:spPr>
+        <p:style>
+          <a:lnRef idx="1">
+            <a:schemeClr val="accent1"/>
+          </a:lnRef>
+          <a:fillRef idx="3">
+            <a:schemeClr val="accent1"/>
+          </a:fillRef>
+          <a:effectRef idx="2">
+            <a:schemeClr val="accent1"/>
+          </a:effectRef>
+          <a:fontRef idx="minor">
+            <a:schemeClr val="lt1"/>
+          </a:fontRef>
+        </p:style>
+        <p:txBody>
+          <a:bodyPr rtlCol="0" anchor="ctr"/>
+          <a:lstStyle/>
+          <a:p/>
+        </p:txBody>
+      </p:sp>
+      <p:sp>
+        <p:nvSpPr>
+          <p:cNvPr id="484" name="TextBox 483"/>
+          <p:cNvSpPr txBox="1"/>
+          <p:nvPr/>
+        </p:nvSpPr>
+        <p:spPr>
+          <a:xfrm>
+            <a:off x="1051560" y="5257800"/>
+            <a:ext cx="7772400" cy="777240"/>
+          </a:xfrm>
+          <a:prstGeom prst="rect">
+            <a:avLst/>
+          </a:prstGeom>
+          <a:noFill/>
+        </p:spPr>
+        <p:txBody>
+          <a:bodyPr wrap="square" lIns="0" rIns="0" tIns="0" bIns="0" anchor="ctr">
+            <a:spAutoFit/>
+          </a:bodyPr>
+          <a:lstStyle/>
+          <a:p>
+            <a:pPr algn="l">
+              <a:lnSpc>
+                <a:spcPct val="130000"/>
+              </a:lnSpc>
+            </a:pPr>
+            <a:r>
+              <a:rPr sz="1700" b="0" i="1">
+                <a:solidFill>
+                  <a:srgbClr val="FFFFFF"/>
+                </a:solidFill>
+                <a:latin typeface="Times New Roman"/>
+              </a:rPr>
+              <a:t>Measure the throw. Explain the miss. Coach only what the data supports.</a:t>
+            </a:r>
+          </a:p>
+        </p:txBody>
+      </p:sp>
+      <p:sp>
+        <p:nvSpPr>
+          <p:cNvPr id="485" name="TextBox 484"/>
+          <p:cNvSpPr txBox="1"/>
+          <p:nvPr/>
+        </p:nvSpPr>
+        <p:spPr>
+          <a:xfrm>
+            <a:off x="8961120" y="5257800"/>
+            <a:ext cx="2240280" cy="777240"/>
+          </a:xfrm>
+          <a:prstGeom prst="rect">
+            <a:avLst/>
+          </a:prstGeom>
+          <a:noFill/>
+        </p:spPr>
+        <p:txBody>
+          <a:bodyPr wrap="square" lIns="0" rIns="0" tIns="0" bIns="0" anchor="ctr">
+            <a:spAutoFit/>
+          </a:bodyPr>
+          <a:lstStyle/>
+          <a:p>
+            <a:pPr algn="r">
+              <a:lnSpc>
+                <a:spcPct val="130000"/>
+              </a:lnSpc>
+            </a:pPr>
+            <a:r>
+              <a:rPr sz="2600" b="1" i="0">
+                <a:solidFill>
+                  <a:srgbClr val="C9A45C"/>
+                </a:solidFill>
+                <a:latin typeface="Times New Roman"/>
+              </a:rPr>
+              <a:t>Questions?</a:t>
+            </a:r>
           </a:p>
         </p:txBody>
       </p:sp>
@@ -25882,7 +28346,7 @@
                 <a:cs typeface="Times New Roman"/>
                 <a:sym typeface="Times New Roman"/>
               </a:rPr>
-              <a:t>Emily Park · 3 / 17</a:t>
+              <a:t>Emily Park · 2 / 12</a:t>
             </a:r>
             <a:endParaRPr b="0" i="0" sz="1200" u="none" cap="none" strike="noStrike">
               <a:solidFill>
@@ -25980,7 +28444,7 @@
                 <a:cs typeface="Times New Roman"/>
                 <a:sym typeface="Times New Roman"/>
               </a:rPr>
-              <a:t>PART 2 · OUR SOLUTION AND WHY</a:t>
+              <a:t>BACKUP · OUR SOLUTION AND WHY</a:t>
             </a:r>
             <a:endParaRPr b="0" i="0" sz="1200" u="none" cap="none" strike="noStrike">
               <a:solidFill>
@@ -27756,7 +30220,7 @@
                 <a:cs typeface="Times New Roman"/>
                 <a:sym typeface="Times New Roman"/>
               </a:rPr>
-              <a:t>Emily Park · 4 / 17</a:t>
+              <a:t>Emily Park · backup</a:t>
             </a:r>
             <a:endParaRPr b="0" i="0" sz="1200" u="none" cap="none" strike="noStrike">
               <a:solidFill>
@@ -27854,7 +30318,7 @@
                 <a:cs typeface="Times New Roman"/>
                 <a:sym typeface="Times New Roman"/>
               </a:rPr>
-              <a:t>PART 2 · THE METRICS WE CHOSE</a:t>
+              <a:t>BACKUP · THE METRICS WE CHOSE</a:t>
             </a:r>
             <a:endParaRPr b="0" i="0" sz="1200" u="none" cap="none" strike="noStrike">
               <a:solidFill>
@@ -30256,7 +32720,7 @@
                 <a:cs typeface="Times New Roman"/>
                 <a:sym typeface="Times New Roman"/>
               </a:rPr>
-              <a:t>John Wilson · 5 / 17</a:t>
+              <a:t>John Wilson · backup</a:t>
             </a:r>
             <a:endParaRPr b="0" i="0" sz="1200" u="none" cap="none" strike="noStrike">
               <a:solidFill>
@@ -31709,7 +34173,7 @@
                 <a:cs typeface="Times New Roman"/>
                 <a:sym typeface="Times New Roman"/>
               </a:rPr>
-              <a:t>John Wilson · 6 / 17</a:t>
+              <a:t>John Wilson · 5 / 12</a:t>
             </a:r>
             <a:endParaRPr b="0" i="0" sz="1200" u="none" cap="none" strike="noStrike">
               <a:solidFill>
@@ -34186,7 +36650,7 @@
                 <a:cs typeface="Times New Roman"/>
                 <a:sym typeface="Times New Roman"/>
               </a:rPr>
-              <a:t>PART 2 · MEASURING REAL PEOPLE</a:t>
+              <a:t>BACKUP · MEASURING REAL PEOPLE</a:t>
             </a:r>
             <a:endParaRPr b="0" i="0" sz="1200" u="none" cap="none" strike="noStrike">
               <a:solidFill>
@@ -36534,7 +38998,7 @@
                 <a:cs typeface="Times New Roman"/>
                 <a:sym typeface="Times New Roman"/>
               </a:rPr>
-              <a:t>John Wilson · 7 / 17</a:t>
+              <a:t>John Wilson · backup</a:t>
             </a:r>
             <a:endParaRPr b="0" i="0" sz="1200" u="none" cap="none" strike="noStrike">
               <a:solidFill>
@@ -37619,7 +40083,7 @@
                 <a:cs typeface="Times New Roman"/>
                 <a:sym typeface="Times New Roman"/>
               </a:rPr>
-              <a:t>Berk Kasimcan · 8 / 17</a:t>
+              <a:t>Berk Kasimcan · 7 / 12</a:t>
             </a:r>
             <a:endParaRPr b="0" i="0" sz="1200" u="none" cap="none" strike="noStrike">
               <a:solidFill>
@@ -37650,7 +40114,7 @@
         <p:spPr>
           <a:xfrm>
             <a:off x="822960" y="2852928"/>
-            <a:ext cx="10552176" cy="2810858"/>
+            <a:ext cx="10552176" cy="2829954"/>
           </a:xfrm>
           <a:prstGeom prst="rect">
             <a:avLst/>
@@ -37665,7 +40129,7 @@
         </p:nvSpPr>
         <p:spPr>
           <a:xfrm>
-            <a:off x="822960" y="5736938"/>
+            <a:off x="822960" y="5756034"/>
             <a:ext cx="10552176" cy="228600"/>
           </a:xfrm>
           <a:prstGeom prst="rect">

</xml_diff>